<commit_message>
docs: correct lesson 11 deck semantics
</commit_message>
<xml_diff>
--- a/decks/11-plan-and-execute-analyst.pptx
+++ b/decks/11-plan-and-execute-analyst.pptx
@@ -2,21 +2,21 @@
 <file path=ppt/presentation.xml><?xml version="1.0" encoding="utf-8"?>
 <p:presentation xmlns:p="http://schemas.openxmlformats.org/presentationml/2006/main">
   <p:sldMasterIdLst>
-    <p:sldMasterId xmlns:r="http://schemas.openxmlformats.org/officeDocument/2006/relationships" id="2147483648" r:id="Ra5b60588e1ec4ce4"/>
+    <p:sldMasterId xmlns:r="http://schemas.openxmlformats.org/officeDocument/2006/relationships" id="2147483648" r:id="Rda229c1d0d1b4ef0"/>
   </p:sldMasterIdLst>
   <p:notesMasterIdLst>
-    <p:notesMasterId xmlns:r="http://schemas.openxmlformats.org/officeDocument/2006/relationships" r:id="R93ce6d1277f64dd9"/>
+    <p:notesMasterId xmlns:r="http://schemas.openxmlformats.org/officeDocument/2006/relationships" r:id="Ra3b438a9cd6a4b55"/>
   </p:notesMasterIdLst>
   <p:sldIdLst>
-    <p:sldId xmlns:r="http://schemas.openxmlformats.org/officeDocument/2006/relationships" id="256" r:id="Re843297383ab4e39"/>
-    <p:sldId xmlns:r="http://schemas.openxmlformats.org/officeDocument/2006/relationships" id="257" r:id="R902e184085944c0e"/>
-    <p:sldId xmlns:r="http://schemas.openxmlformats.org/officeDocument/2006/relationships" id="258" r:id="Rf9fd6731b3cd4ccb"/>
-    <p:sldId xmlns:r="http://schemas.openxmlformats.org/officeDocument/2006/relationships" id="259" r:id="Ra402a03ff0a24231"/>
-    <p:sldId xmlns:r="http://schemas.openxmlformats.org/officeDocument/2006/relationships" id="260" r:id="R6fe6c2c7ca5b4aac"/>
-    <p:sldId xmlns:r="http://schemas.openxmlformats.org/officeDocument/2006/relationships" id="261" r:id="R93d8dc567d8449eb"/>
-    <p:sldId xmlns:r="http://schemas.openxmlformats.org/officeDocument/2006/relationships" id="262" r:id="R2af32b3d710c4b5b"/>
-    <p:sldId xmlns:r="http://schemas.openxmlformats.org/officeDocument/2006/relationships" id="263" r:id="Re5076e6684eb4787"/>
-    <p:sldId xmlns:r="http://schemas.openxmlformats.org/officeDocument/2006/relationships" id="264" r:id="Rf3f3d156f27542c3"/>
+    <p:sldId xmlns:r="http://schemas.openxmlformats.org/officeDocument/2006/relationships" id="256" r:id="Rb8d128f2758a44a4"/>
+    <p:sldId xmlns:r="http://schemas.openxmlformats.org/officeDocument/2006/relationships" id="257" r:id="Re8f4be3127d74d69"/>
+    <p:sldId xmlns:r="http://schemas.openxmlformats.org/officeDocument/2006/relationships" id="258" r:id="R6256ee6f83da4100"/>
+    <p:sldId xmlns:r="http://schemas.openxmlformats.org/officeDocument/2006/relationships" id="259" r:id="Rcea383fc9b1b4cbe"/>
+    <p:sldId xmlns:r="http://schemas.openxmlformats.org/officeDocument/2006/relationships" id="260" r:id="R39600d7e2f7649c5"/>
+    <p:sldId xmlns:r="http://schemas.openxmlformats.org/officeDocument/2006/relationships" id="261" r:id="R9f5e78001b7d430c"/>
+    <p:sldId xmlns:r="http://schemas.openxmlformats.org/officeDocument/2006/relationships" id="262" r:id="Rdd616f6087a34a03"/>
+    <p:sldId xmlns:r="http://schemas.openxmlformats.org/officeDocument/2006/relationships" id="263" r:id="R55387e52e1314bc6"/>
+    <p:sldId xmlns:r="http://schemas.openxmlformats.org/officeDocument/2006/relationships" id="264" r:id="R0ffe65df072e444e"/>
   </p:sldIdLst>
   <p:sldSz cx="15240000" cy="8572500"/>
   <p:notesSz cx="6858000" cy="9144000"/>
@@ -1055,7 +1055,7 @@
           </a:p>
           <a:p xmlns:a="http://schemas.openxmlformats.org/drawingml/2006/main">
             <a:r>
-              <a:t>https://github.com/graviraja/MLOps-Basics/tree/main</a:t>
+              <a:t>https://docs.langchain.com/langsmith/evaluation-concepts</a:t>
             </a:r>
           </a:p>
           <a:p xmlns:a="http://schemas.openxmlformats.org/drawingml/2006/main">
@@ -1140,7 +1140,7 @@
           </a:p>
           <a:p xmlns:a="http://schemas.openxmlformats.org/drawingml/2006/main">
             <a:r>
-              <a:t>https://github.com/graviraja/MLOps-Basics/tree/main</a:t>
+              <a:t>https://docs.langchain.com/langsmith/evaluate-complex-agent</a:t>
             </a:r>
           </a:p>
           <a:p xmlns:a="http://schemas.openxmlformats.org/drawingml/2006/main">
@@ -1213,7 +1213,7 @@
   </p:cSld>
   <p:clrMap bg1="lt1" tx1="dk1" bg2="lt2" tx2="dk2" accent1="accent1" accent2="accent2" accent3="accent3" accent4="accent4" accent5="accent5" accent6="accent6" hlink="hlink" folHlink="folHlink"/>
   <p:sldLayoutIdLst>
-    <p:sldLayoutId xmlns:r="http://schemas.openxmlformats.org/officeDocument/2006/relationships" id="2147483649" r:id="Rcafe507d51f34c75"/>
+    <p:sldLayoutId xmlns:r="http://schemas.openxmlformats.org/officeDocument/2006/relationships" id="2147483649" r:id="R78ffe64b28b842c1"/>
   </p:sldLayoutIdLst>
   <p:txStyles>
     <p:titleStyle>
@@ -7264,10 +7264,10 @@
       </p:grpSpPr>
       <p:sp>
         <p:nvSpPr>
-          <p:cNvPr id="35" name="">
-            <a:extLst xmlns:a="http://schemas.openxmlformats.org/drawingml/2006/main">
-              <a:ext uri="{FF2B5EF4-FFF2-40B4-BE49-F238E27FC236}">
-                <a16:creationId xmlns:a16="http://schemas.microsoft.com/office/drawing/2014/main" id="{45EAFBC5-0120-406B-9113-A189734D7D27}"/>
+          <p:cNvPr id="28" name="">
+            <a:extLst xmlns:a="http://schemas.openxmlformats.org/drawingml/2006/main">
+              <a:ext uri="{FF2B5EF4-FFF2-40B4-BE49-F238E27FC236}">
+                <a16:creationId xmlns:a16="http://schemas.microsoft.com/office/drawing/2014/main" id="{5D84E1CF-DA64-4EFC-8528-B207517D3ECD}"/>
               </a:ext>
             </a:extLst>
           </p:cNvPr>
@@ -7329,7 +7329,7 @@
           <p:cNvPr id="2" name="">
             <a:extLst xmlns:a="http://schemas.openxmlformats.org/drawingml/2006/main">
               <a:ext uri="{FF2B5EF4-FFF2-40B4-BE49-F238E27FC236}">
-                <a16:creationId xmlns:a16="http://schemas.microsoft.com/office/drawing/2014/main" id="{E788E1BA-062C-4D13-89C4-9762E55DD5F6}"/>
+                <a16:creationId xmlns:a16="http://schemas.microsoft.com/office/drawing/2014/main" id="{0AEDDB7F-E2AD-4762-B051-D3A0AC293CCB}"/>
               </a:ext>
             </a:extLst>
           </p:cNvPr>
@@ -7388,26 +7388,26 @@
       </p:sp>
       <p:sp>
         <p:nvSpPr>
-          <p:cNvPr id="3" name="ingestion-1">
-            <a:extLst xmlns:a="http://schemas.openxmlformats.org/drawingml/2006/main">
-              <a:ext uri="{FF2B5EF4-FFF2-40B4-BE49-F238E27FC236}">
-                <a16:creationId xmlns:a16="http://schemas.microsoft.com/office/drawing/2014/main" id="{EF5CEA91-0836-4E99-95C1-43A271A11FFF}"/>
-              </a:ext>
-            </a:extLst>
-          </p:cNvPr>
-          <p:cNvSpPr>
-            <a:spLocks xmlns:a="http://schemas.openxmlformats.org/drawingml/2006/main" noGrp="1"/>
-          </p:cNvSpPr>
-          <p:nvPr/>
-        </p:nvSpPr>
-        <p:spPr>
-          <a:xfrm xmlns:a="http://schemas.openxmlformats.org/drawingml/2006/main">
-            <a:off x="990600" y="3086100"/>
-            <a:ext cx="2247900" cy="2266950"/>
+          <p:cNvPr id="3" name="decision-source">
+            <a:extLst xmlns:a="http://schemas.openxmlformats.org/drawingml/2006/main">
+              <a:ext uri="{FF2B5EF4-FFF2-40B4-BE49-F238E27FC236}">
+                <a16:creationId xmlns:a16="http://schemas.microsoft.com/office/drawing/2014/main" id="{F0F1628B-25FC-4A7D-9ACB-11ED41518DD3}"/>
+              </a:ext>
+            </a:extLst>
+          </p:cNvPr>
+          <p:cNvSpPr>
+            <a:spLocks xmlns:a="http://schemas.openxmlformats.org/drawingml/2006/main" noGrp="1"/>
+          </p:cNvSpPr>
+          <p:nvPr/>
+        </p:nvSpPr>
+        <p:spPr>
+          <a:xfrm xmlns:a="http://schemas.openxmlformats.org/drawingml/2006/main">
+            <a:off x="1028700" y="2990850"/>
+            <a:ext cx="2724150" cy="1562100"/>
           </a:xfrm>
           <a:prstGeom xmlns:a="http://schemas.openxmlformats.org/drawingml/2006/main" prst="roundRect">
             <a:avLst>
-              <a:gd name="adj" fmla="val 5085"/>
+              <a:gd name="adj" fmla="val 7317"/>
             </a:avLst>
           </a:prstGeom>
           <a:solidFill xmlns:a="http://schemas.openxmlformats.org/drawingml/2006/main">
@@ -7426,19 +7426,19 @@
           <p:cNvPr id="4" name="">
             <a:extLst xmlns:a="http://schemas.openxmlformats.org/drawingml/2006/main">
               <a:ext uri="{FF2B5EF4-FFF2-40B4-BE49-F238E27FC236}">
-                <a16:creationId xmlns:a16="http://schemas.microsoft.com/office/drawing/2014/main" id="{4A163ADC-FDBA-49AB-AB53-62FA29104479}"/>
-              </a:ext>
-            </a:extLst>
-          </p:cNvPr>
-          <p:cNvSpPr>
-            <a:spLocks xmlns:a="http://schemas.openxmlformats.org/drawingml/2006/main" noGrp="1"/>
-          </p:cNvSpPr>
-          <p:nvPr/>
-        </p:nvSpPr>
-        <p:spPr>
-          <a:xfrm xmlns:a="http://schemas.openxmlformats.org/drawingml/2006/main">
-            <a:off x="1181100" y="3295650"/>
-            <a:ext cx="514350" cy="285750"/>
+                <a16:creationId xmlns:a16="http://schemas.microsoft.com/office/drawing/2014/main" id="{62CDE4FD-810A-4BB6-A9E2-9D453E2B432E}"/>
+              </a:ext>
+            </a:extLst>
+          </p:cNvPr>
+          <p:cNvSpPr>
+            <a:spLocks xmlns:a="http://schemas.openxmlformats.org/drawingml/2006/main" noGrp="1"/>
+          </p:cNvSpPr>
+          <p:nvPr/>
+        </p:nvSpPr>
+        <p:spPr>
+          <a:xfrm xmlns:a="http://schemas.openxmlformats.org/drawingml/2006/main">
+            <a:off x="1295400" y="3181350"/>
+            <a:ext cx="2190750" cy="323850"/>
           </a:xfrm>
           <a:prstGeom xmlns:a="http://schemas.openxmlformats.org/drawingml/2006/main" prst="rect">
             <a:avLst/>
@@ -7455,14 +7455,14 @@
           </a:bodyPr>
           <a:lstStyle xmlns:a="http://schemas.openxmlformats.org/drawingml/2006/main"/>
           <a:p xmlns:a="http://schemas.openxmlformats.org/drawingml/2006/main">
-            <a:pPr algn="l">
+            <a:pPr algn="ctr">
               <a:lnSpc>
                 <a:spcPct val="100000"/>
               </a:lnSpc>
               <a:buNone/>
               <a:defRPr sz="1350" b="1">
                 <a:solidFill>
-                  <a:srgbClr val="00A2EB"/>
+                  <a:srgbClr val="1F40CB"/>
                 </a:solidFill>
                 <a:latin typeface="Calibri"/>
                 <a:ea typeface="Calibri"/>
@@ -7472,13 +7472,13 @@
             <a:r>
               <a:rPr sz="1800" b="1">
                 <a:solidFill>
-                  <a:srgbClr val="00A2EB"/>
-                </a:solidFill>
-                <a:latin typeface="Calibri"/>
-                <a:ea typeface="Calibri"/>
-                <a:cs typeface="Calibri"/>
-              </a:rPr>
-              <a:t>01</a:t>
+                  <a:srgbClr val="1F40CB"/>
+                </a:solidFill>
+                <a:latin typeface="Calibri"/>
+                <a:ea typeface="Calibri"/>
+                <a:cs typeface="Calibri"/>
+              </a:rPr>
+              <a:t>PLAN + REPLAN</a:t>
             </a:r>
           </a:p>
         </p:txBody>
@@ -7488,19 +7488,19 @@
           <p:cNvPr id="5" name="">
             <a:extLst xmlns:a="http://schemas.openxmlformats.org/drawingml/2006/main">
               <a:ext uri="{FF2B5EF4-FFF2-40B4-BE49-F238E27FC236}">
-                <a16:creationId xmlns:a16="http://schemas.microsoft.com/office/drawing/2014/main" id="{26D1AD73-F995-4369-A266-8FA41354CE3D}"/>
-              </a:ext>
-            </a:extLst>
-          </p:cNvPr>
-          <p:cNvSpPr>
-            <a:spLocks xmlns:a="http://schemas.openxmlformats.org/drawingml/2006/main" noGrp="1"/>
-          </p:cNvSpPr>
-          <p:nvPr/>
-        </p:nvSpPr>
-        <p:spPr>
-          <a:xfrm xmlns:a="http://schemas.openxmlformats.org/drawingml/2006/main">
-            <a:off x="1104900" y="3752850"/>
-            <a:ext cx="2019300" cy="685800"/>
+                <a16:creationId xmlns:a16="http://schemas.microsoft.com/office/drawing/2014/main" id="{25AA52CC-262C-4723-8C2E-E43262748B6A}"/>
+              </a:ext>
+            </a:extLst>
+          </p:cNvPr>
+          <p:cNvSpPr>
+            <a:spLocks xmlns:a="http://schemas.openxmlformats.org/drawingml/2006/main" noGrp="1"/>
+          </p:cNvSpPr>
+          <p:nvPr/>
+        </p:nvSpPr>
+        <p:spPr>
+          <a:xfrm xmlns:a="http://schemas.openxmlformats.org/drawingml/2006/main">
+            <a:off x="1295400" y="3657600"/>
+            <a:ext cx="2190750" cy="647700"/>
           </a:xfrm>
           <a:prstGeom xmlns:a="http://schemas.openxmlformats.org/drawingml/2006/main" prst="rect">
             <a:avLst/>
@@ -7517,12 +7517,12 @@
           </a:bodyPr>
           <a:lstStyle xmlns:a="http://schemas.openxmlformats.org/drawingml/2006/main"/>
           <a:p xmlns:a="http://schemas.openxmlformats.org/drawingml/2006/main">
-            <a:pPr algn="l">
-              <a:lnSpc>
-                <a:spcPct val="100000"/>
-              </a:lnSpc>
-              <a:buNone/>
-              <a:defRPr sz="1950" b="1">
+            <a:pPr algn="ctr">
+              <a:lnSpc>
+                <a:spcPct val="100000"/>
+              </a:lnSpc>
+              <a:buNone/>
+              <a:defRPr sz="1650" b="1">
                 <a:solidFill>
                   <a:srgbClr val="051C2A"/>
                 </a:solidFill>
@@ -7532,7 +7532,7 @@
               </a:defRPr>
             </a:pPr>
             <a:r>
-              <a:rPr sz="1950" b="1">
+              <a:rPr sz="1650" b="1">
                 <a:solidFill>
                   <a:srgbClr val="051C2A"/>
                 </a:solidFill>
@@ -7540,95 +7540,627 @@
                 <a:ea typeface="Calibri"/>
                 <a:cs typeface="Calibri"/>
               </a:rPr>
-              <a:t>PLANNER</a:t>
-            </a:r>
-          </a:p>
-        </p:txBody>
-      </p:sp>
-      <p:sp>
-        <p:nvSpPr>
-          <p:cNvPr id="6" name="">
-            <a:extLst xmlns:a="http://schemas.openxmlformats.org/drawingml/2006/main">
-              <a:ext uri="{FF2B5EF4-FFF2-40B4-BE49-F238E27FC236}">
-                <a16:creationId xmlns:a16="http://schemas.microsoft.com/office/drawing/2014/main" id="{4CA7F72B-07B6-4BF4-A3F9-5860F8AC7245}"/>
-              </a:ext>
-            </a:extLst>
-          </p:cNvPr>
-          <p:cNvSpPr>
-            <a:spLocks xmlns:a="http://schemas.openxmlformats.org/drawingml/2006/main" noGrp="1"/>
-          </p:cNvSpPr>
-          <p:nvPr/>
-        </p:nvSpPr>
-        <p:spPr>
-          <a:xfrm xmlns:a="http://schemas.openxmlformats.org/drawingml/2006/main">
-            <a:off x="1181100" y="4610100"/>
-            <a:ext cx="1866900" cy="514350"/>
-          </a:xfrm>
-          <a:prstGeom xmlns:a="http://schemas.openxmlformats.org/drawingml/2006/main" prst="rect">
-            <a:avLst/>
-          </a:prstGeom>
-          <a:noFill xmlns:a="http://schemas.openxmlformats.org/drawingml/2006/main"/>
-          <a:ln xmlns:a="http://schemas.openxmlformats.org/drawingml/2006/main" w="0">
-            <a:noFill/>
-            <a:prstDash val="solid"/>
-          </a:ln>
-        </p:spPr>
-        <p:txBody>
-          <a:bodyPr xmlns:a="http://schemas.openxmlformats.org/drawingml/2006/main" wrap="square" lIns="0" tIns="0" rIns="0" bIns="0" anchor="ctr">
-            <a:normAutofit fontScale="100000"/>
-          </a:bodyPr>
-          <a:lstStyle xmlns:a="http://schemas.openxmlformats.org/drawingml/2006/main"/>
-          <a:p xmlns:a="http://schemas.openxmlformats.org/drawingml/2006/main">
-            <a:pPr algn="l">
-              <a:lnSpc>
-                <a:spcPct val="100000"/>
-              </a:lnSpc>
-              <a:buNone/>
-              <a:defRPr sz="1200" b="0">
-                <a:solidFill>
-                  <a:srgbClr val="1F40CB"/>
-                </a:solidFill>
-                <a:latin typeface="Calibri"/>
-                <a:ea typeface="Calibri"/>
-                <a:cs typeface="Calibri"/>
-              </a:defRPr>
-            </a:pPr>
-            <a:r>
-              <a:rPr sz="1200" b="0">
-                <a:solidFill>
-                  <a:srgbClr val="1F40CB"/>
-                </a:solidFill>
-                <a:latin typeface="Calibri"/>
-                <a:ea typeface="Calibri"/>
-                <a:cs typeface="Calibri"/>
-              </a:rPr>
-              <a:t>proposes plan</a:t>
-            </a:r>
-          </a:p>
-        </p:txBody>
-      </p:sp>
-      <p:sp>
-        <p:nvSpPr>
-          <p:cNvPr id="7" name="ingestion-2">
-            <a:extLst xmlns:a="http://schemas.openxmlformats.org/drawingml/2006/main">
-              <a:ext uri="{FF2B5EF4-FFF2-40B4-BE49-F238E27FC236}">
-                <a16:creationId xmlns:a16="http://schemas.microsoft.com/office/drawing/2014/main" id="{B39DEECB-E0D1-415A-8F2A-C8075A6D97BA}"/>
-              </a:ext>
-            </a:extLst>
-          </p:cNvPr>
-          <p:cNvSpPr>
-            <a:spLocks xmlns:a="http://schemas.openxmlformats.org/drawingml/2006/main" noGrp="1"/>
-          </p:cNvSpPr>
-          <p:nvPr/>
-        </p:nvSpPr>
-        <p:spPr>
-          <a:xfrm xmlns:a="http://schemas.openxmlformats.org/drawingml/2006/main">
-            <a:off x="3810000" y="3086100"/>
-            <a:ext cx="2247900" cy="2266950"/>
+              <a:t>PLANNER proposes</a:t>
+            </a:r>
+          </a:p>
+          <a:p xmlns:a="http://schemas.openxmlformats.org/drawingml/2006/main">
+            <a:pPr algn="ctr">
+              <a:lnSpc>
+                <a:spcPct val="100000"/>
+              </a:lnSpc>
+              <a:buNone/>
+              <a:defRPr sz="1650" b="1">
+                <a:solidFill>
+                  <a:srgbClr val="051C2A"/>
+                </a:solidFill>
+                <a:latin typeface="Calibri"/>
+                <a:ea typeface="Calibri"/>
+                <a:cs typeface="Calibri"/>
+              </a:defRPr>
+            </a:pPr>
+            <a:r>
+              <a:rPr sz="1650" b="1">
+                <a:solidFill>
+                  <a:srgbClr val="051C2A"/>
+                </a:solidFill>
+                <a:latin typeface="Calibri"/>
+                <a:ea typeface="Calibri"/>
+                <a:cs typeface="Calibri"/>
+              </a:rPr>
+              <a:t>REPLANNER revises</a:t>
+            </a:r>
+          </a:p>
+        </p:txBody>
+      </p:sp>
+      <p:sp>
+        <p:nvSpPr>
+          <p:cNvPr id="6" name="decision-child">
+            <a:extLst xmlns:a="http://schemas.openxmlformats.org/drawingml/2006/main">
+              <a:ext uri="{FF2B5EF4-FFF2-40B4-BE49-F238E27FC236}">
+                <a16:creationId xmlns:a16="http://schemas.microsoft.com/office/drawing/2014/main" id="{E359D7F5-9555-4867-8587-2F8EC5254E07}"/>
+              </a:ext>
+            </a:extLst>
+          </p:cNvPr>
+          <p:cNvSpPr>
+            <a:spLocks xmlns:a="http://schemas.openxmlformats.org/drawingml/2006/main" noGrp="1"/>
+          </p:cNvSpPr>
+          <p:nvPr/>
+        </p:nvSpPr>
+        <p:spPr>
+          <a:xfrm xmlns:a="http://schemas.openxmlformats.org/drawingml/2006/main">
+            <a:off x="5162550" y="2857500"/>
+            <a:ext cx="3257550" cy="1828800"/>
           </a:xfrm>
           <a:prstGeom xmlns:a="http://schemas.openxmlformats.org/drawingml/2006/main" prst="roundRect">
             <a:avLst>
-              <a:gd name="adj" fmla="val 5085"/>
+              <a:gd name="adj" fmla="val 6250"/>
+            </a:avLst>
+          </a:prstGeom>
+          <a:solidFill xmlns:a="http://schemas.openxmlformats.org/drawingml/2006/main">
+            <a:srgbClr val="E8F6FB"/>
+          </a:solidFill>
+          <a:ln xmlns:a="http://schemas.openxmlformats.org/drawingml/2006/main" w="19050">
+            <a:solidFill>
+              <a:srgbClr val="00A2EB"/>
+            </a:solidFill>
+            <a:prstDash val="solid"/>
+          </a:ln>
+        </p:spPr>
+      </p:sp>
+      <p:sp>
+        <p:nvSpPr>
+          <p:cNvPr id="7" name="">
+            <a:extLst xmlns:a="http://schemas.openxmlformats.org/drawingml/2006/main">
+              <a:ext uri="{FF2B5EF4-FFF2-40B4-BE49-F238E27FC236}">
+                <a16:creationId xmlns:a16="http://schemas.microsoft.com/office/drawing/2014/main" id="{14C45E62-2BDC-4F11-8E8E-92ACD6B6E61D}"/>
+              </a:ext>
+            </a:extLst>
+          </p:cNvPr>
+          <p:cNvSpPr>
+            <a:spLocks xmlns:a="http://schemas.openxmlformats.org/drawingml/2006/main" noGrp="1"/>
+          </p:cNvSpPr>
+          <p:nvPr/>
+        </p:nvSpPr>
+        <p:spPr>
+          <a:xfrm xmlns:a="http://schemas.openxmlformats.org/drawingml/2006/main">
+            <a:off x="5467350" y="2914650"/>
+            <a:ext cx="2647950" cy="476250"/>
+          </a:xfrm>
+          <a:prstGeom xmlns:a="http://schemas.openxmlformats.org/drawingml/2006/main" prst="rect">
+            <a:avLst/>
+          </a:prstGeom>
+          <a:noFill xmlns:a="http://schemas.openxmlformats.org/drawingml/2006/main"/>
+          <a:ln xmlns:a="http://schemas.openxmlformats.org/drawingml/2006/main" w="0">
+            <a:noFill/>
+            <a:prstDash val="solid"/>
+          </a:ln>
+        </p:spPr>
+        <p:txBody>
+          <a:bodyPr xmlns:a="http://schemas.openxmlformats.org/drawingml/2006/main" wrap="square" lIns="0" tIns="0" rIns="0" bIns="0" anchor="ctr">
+            <a:noAutofit/>
+          </a:bodyPr>
+          <a:lstStyle xmlns:a="http://schemas.openxmlformats.org/drawingml/2006/main"/>
+          <a:p xmlns:a="http://schemas.openxmlformats.org/drawingml/2006/main">
+            <a:pPr algn="ctr">
+              <a:lnSpc>
+                <a:spcPct val="100000"/>
+              </a:lnSpc>
+              <a:buNone/>
+              <a:defRPr sz="1275" b="1">
+                <a:solidFill>
+                  <a:srgbClr val="00A2EB"/>
+                </a:solidFill>
+                <a:latin typeface="Calibri"/>
+                <a:ea typeface="Calibri"/>
+                <a:cs typeface="Calibri"/>
+              </a:defRPr>
+            </a:pPr>
+            <a:r>
+              <a:rPr sz="1800" b="1">
+                <a:solidFill>
+                  <a:srgbClr val="00A2EB"/>
+                </a:solidFill>
+                <a:latin typeface="Calibri"/>
+                <a:ea typeface="Calibri"/>
+                <a:cs typeface="Calibri"/>
+              </a:rPr>
+              <a:t>HOST</a:t>
+            </a:r>
+          </a:p>
+          <a:p xmlns:a="http://schemas.openxmlformats.org/drawingml/2006/main">
+            <a:pPr algn="ctr">
+              <a:lnSpc>
+                <a:spcPct val="100000"/>
+              </a:lnSpc>
+              <a:buNone/>
+              <a:defRPr sz="1275" b="1">
+                <a:solidFill>
+                  <a:srgbClr val="00A2EB"/>
+                </a:solidFill>
+                <a:latin typeface="Calibri"/>
+                <a:ea typeface="Calibri"/>
+                <a:cs typeface="Calibri"/>
+              </a:defRPr>
+            </a:pPr>
+            <a:r>
+              <a:rPr sz="1800" b="1">
+                <a:solidFill>
+                  <a:srgbClr val="00A2EB"/>
+                </a:solidFill>
+                <a:latin typeface="Calibri"/>
+                <a:ea typeface="Calibri"/>
+                <a:cs typeface="Calibri"/>
+              </a:rPr>
+              <a:t>STATE</a:t>
+            </a:r>
+          </a:p>
+        </p:txBody>
+      </p:sp>
+      <p:sp>
+        <p:nvSpPr>
+          <p:cNvPr id="8" name="">
+            <a:extLst xmlns:a="http://schemas.openxmlformats.org/drawingml/2006/main">
+              <a:ext uri="{FF2B5EF4-FFF2-40B4-BE49-F238E27FC236}">
+                <a16:creationId xmlns:a16="http://schemas.microsoft.com/office/drawing/2014/main" id="{9FF2A998-C21C-458F-BEED-486513923D87}"/>
+              </a:ext>
+            </a:extLst>
+          </p:cNvPr>
+          <p:cNvSpPr>
+            <a:spLocks xmlns:a="http://schemas.openxmlformats.org/drawingml/2006/main" noGrp="1"/>
+          </p:cNvSpPr>
+          <p:nvPr/>
+        </p:nvSpPr>
+        <p:spPr>
+          <a:xfrm xmlns:a="http://schemas.openxmlformats.org/drawingml/2006/main">
+            <a:off x="5467350" y="3390900"/>
+            <a:ext cx="2647950" cy="800100"/>
+          </a:xfrm>
+          <a:prstGeom xmlns:a="http://schemas.openxmlformats.org/drawingml/2006/main" prst="rect">
+            <a:avLst/>
+          </a:prstGeom>
+          <a:noFill xmlns:a="http://schemas.openxmlformats.org/drawingml/2006/main"/>
+          <a:ln xmlns:a="http://schemas.openxmlformats.org/drawingml/2006/main" w="0">
+            <a:noFill/>
+            <a:prstDash val="solid"/>
+          </a:ln>
+        </p:spPr>
+        <p:txBody>
+          <a:bodyPr xmlns:a="http://schemas.openxmlformats.org/drawingml/2006/main" wrap="square" lIns="0" tIns="0" rIns="0" bIns="0" anchor="ctr">
+            <a:noAutofit/>
+          </a:bodyPr>
+          <a:lstStyle xmlns:a="http://schemas.openxmlformats.org/drawingml/2006/main"/>
+          <a:p xmlns:a="http://schemas.openxmlformats.org/drawingml/2006/main">
+            <a:pPr algn="ctr">
+              <a:lnSpc>
+                <a:spcPct val="80000"/>
+              </a:lnSpc>
+              <a:buNone/>
+              <a:defRPr sz="2175" b="1">
+                <a:solidFill>
+                  <a:srgbClr val="051C2A"/>
+                </a:solidFill>
+                <a:latin typeface="Calibri"/>
+                <a:ea typeface="Calibri"/>
+                <a:cs typeface="Calibri"/>
+              </a:defRPr>
+            </a:pPr>
+            <a:r>
+              <a:rPr sz="1800" b="1">
+                <a:solidFill>
+                  <a:srgbClr val="051C2A"/>
+                </a:solidFill>
+                <a:latin typeface="Calibri"/>
+                <a:ea typeface="Calibri"/>
+                <a:cs typeface="Calibri"/>
+              </a:rPr>
+              <a:t>mission · plan</a:t>
+            </a:r>
+          </a:p>
+          <a:p xmlns:a="http://schemas.openxmlformats.org/drawingml/2006/main">
+            <a:pPr algn="ctr">
+              <a:lnSpc>
+                <a:spcPct val="80000"/>
+              </a:lnSpc>
+              <a:buNone/>
+              <a:defRPr sz="2175" b="1">
+                <a:solidFill>
+                  <a:srgbClr val="051C2A"/>
+                </a:solidFill>
+                <a:latin typeface="Calibri"/>
+                <a:ea typeface="Calibri"/>
+                <a:cs typeface="Calibri"/>
+              </a:defRPr>
+            </a:pPr>
+            <a:r>
+              <a:rPr sz="1800" b="1">
+                <a:solidFill>
+                  <a:srgbClr val="051C2A"/>
+                </a:solidFill>
+                <a:latin typeface="Calibri"/>
+                <a:ea typeface="Calibri"/>
+                <a:cs typeface="Calibri"/>
+              </a:rPr>
+              <a:t>observations · budgets</a:t>
+            </a:r>
+          </a:p>
+          <a:p xmlns:a="http://schemas.openxmlformats.org/drawingml/2006/main">
+            <a:pPr algn="ctr">
+              <a:lnSpc>
+                <a:spcPct val="80000"/>
+              </a:lnSpc>
+              <a:buNone/>
+              <a:defRPr sz="2175" b="1">
+                <a:solidFill>
+                  <a:srgbClr val="051C2A"/>
+                </a:solidFill>
+                <a:latin typeface="Calibri"/>
+                <a:ea typeface="Calibri"/>
+                <a:cs typeface="Calibri"/>
+              </a:defRPr>
+            </a:pPr>
+            <a:r>
+              <a:rPr sz="1800" b="1">
+                <a:solidFill>
+                  <a:srgbClr val="051C2A"/>
+                </a:solidFill>
+                <a:latin typeface="Calibri"/>
+                <a:ea typeface="Calibri"/>
+                <a:cs typeface="Calibri"/>
+              </a:rPr>
+              <a:t>source references</a:t>
+            </a:r>
+          </a:p>
+        </p:txBody>
+      </p:sp>
+      <p:sp>
+        <p:nvSpPr>
+          <p:cNvPr id="9" name="">
+            <a:extLst xmlns:a="http://schemas.openxmlformats.org/drawingml/2006/main">
+              <a:ext uri="{FF2B5EF4-FFF2-40B4-BE49-F238E27FC236}">
+                <a16:creationId xmlns:a16="http://schemas.microsoft.com/office/drawing/2014/main" id="{EE8A313B-A32E-4318-B50D-32C786561C84}"/>
+              </a:ext>
+            </a:extLst>
+          </p:cNvPr>
+          <p:cNvSpPr>
+            <a:spLocks xmlns:a="http://schemas.openxmlformats.org/drawingml/2006/main" noGrp="1"/>
+          </p:cNvSpPr>
+          <p:nvPr/>
+        </p:nvSpPr>
+        <p:spPr>
+          <a:xfrm xmlns:a="http://schemas.openxmlformats.org/drawingml/2006/main">
+            <a:off x="5467350" y="4191000"/>
+            <a:ext cx="2647950" cy="476250"/>
+          </a:xfrm>
+          <a:prstGeom xmlns:a="http://schemas.openxmlformats.org/drawingml/2006/main" prst="rect">
+            <a:avLst/>
+          </a:prstGeom>
+          <a:noFill xmlns:a="http://schemas.openxmlformats.org/drawingml/2006/main"/>
+          <a:ln xmlns:a="http://schemas.openxmlformats.org/drawingml/2006/main" w="0">
+            <a:noFill/>
+            <a:prstDash val="solid"/>
+          </a:ln>
+        </p:spPr>
+        <p:txBody>
+          <a:bodyPr xmlns:a="http://schemas.openxmlformats.org/drawingml/2006/main" wrap="square" lIns="0" tIns="0" rIns="0" bIns="0" anchor="ctr">
+            <a:noAutofit/>
+          </a:bodyPr>
+          <a:lstStyle xmlns:a="http://schemas.openxmlformats.org/drawingml/2006/main"/>
+          <a:p xmlns:a="http://schemas.openxmlformats.org/drawingml/2006/main">
+            <a:pPr algn="ctr">
+              <a:lnSpc>
+                <a:spcPct val="70000"/>
+              </a:lnSpc>
+              <a:buNone/>
+              <a:defRPr sz="1275" b="0">
+                <a:solidFill>
+                  <a:srgbClr val="1F40CB"/>
+                </a:solidFill>
+                <a:latin typeface="Calibri"/>
+                <a:ea typeface="Calibri"/>
+                <a:cs typeface="Calibri"/>
+              </a:defRPr>
+            </a:pPr>
+            <a:r>
+              <a:rPr sz="1800" b="0">
+                <a:solidFill>
+                  <a:srgbClr val="1F40CB"/>
+                </a:solidFill>
+                <a:latin typeface="Calibri"/>
+                <a:ea typeface="Calibri"/>
+                <a:cs typeface="Calibri"/>
+              </a:rPr>
+              <a:t>append-only · bounded</a:t>
+            </a:r>
+          </a:p>
+          <a:p xmlns:a="http://schemas.openxmlformats.org/drawingml/2006/main">
+            <a:pPr algn="ctr">
+              <a:lnSpc>
+                <a:spcPct val="70000"/>
+              </a:lnSpc>
+              <a:buNone/>
+              <a:defRPr sz="1275" b="0">
+                <a:solidFill>
+                  <a:srgbClr val="1F40CB"/>
+                </a:solidFill>
+                <a:latin typeface="Calibri"/>
+                <a:ea typeface="Calibri"/>
+                <a:cs typeface="Calibri"/>
+              </a:defRPr>
+            </a:pPr>
+            <a:r>
+              <a:rPr sz="1800" b="0">
+                <a:solidFill>
+                  <a:srgbClr val="1F40CB"/>
+                </a:solidFill>
+                <a:latin typeface="Calibri"/>
+                <a:ea typeface="Calibri"/>
+                <a:cs typeface="Calibri"/>
+              </a:rPr>
+              <a:t>shared across nodes</a:t>
+            </a:r>
+          </a:p>
+        </p:txBody>
+      </p:sp>
+      <p:sp>
+        <p:nvSpPr>
+          <p:cNvPr id="10" name="decision-parent">
+            <a:extLst xmlns:a="http://schemas.openxmlformats.org/drawingml/2006/main">
+              <a:ext uri="{FF2B5EF4-FFF2-40B4-BE49-F238E27FC236}">
+                <a16:creationId xmlns:a16="http://schemas.microsoft.com/office/drawing/2014/main" id="{7E8CC043-3F7C-4B5E-B01A-E942C33D8740}"/>
+              </a:ext>
+            </a:extLst>
+          </p:cNvPr>
+          <p:cNvSpPr>
+            <a:spLocks xmlns:a="http://schemas.openxmlformats.org/drawingml/2006/main" noGrp="1"/>
+          </p:cNvSpPr>
+          <p:nvPr/>
+        </p:nvSpPr>
+        <p:spPr>
+          <a:xfrm xmlns:a="http://schemas.openxmlformats.org/drawingml/2006/main">
+            <a:off x="9829800" y="2990850"/>
+            <a:ext cx="3543300" cy="1562100"/>
+          </a:xfrm>
+          <a:prstGeom xmlns:a="http://schemas.openxmlformats.org/drawingml/2006/main" prst="roundRect">
+            <a:avLst>
+              <a:gd name="adj" fmla="val 7317"/>
+            </a:avLst>
+          </a:prstGeom>
+          <a:solidFill xmlns:a="http://schemas.openxmlformats.org/drawingml/2006/main">
+            <a:srgbClr val="062433"/>
+          </a:solidFill>
+          <a:ln xmlns:a="http://schemas.openxmlformats.org/drawingml/2006/main" w="9525">
+            <a:solidFill>
+              <a:srgbClr val="062433"/>
+            </a:solidFill>
+            <a:prstDash val="solid"/>
+          </a:ln>
+        </p:spPr>
+      </p:sp>
+      <p:sp>
+        <p:nvSpPr>
+          <p:cNvPr id="11" name="">
+            <a:extLst xmlns:a="http://schemas.openxmlformats.org/drawingml/2006/main">
+              <a:ext uri="{FF2B5EF4-FFF2-40B4-BE49-F238E27FC236}">
+                <a16:creationId xmlns:a16="http://schemas.microsoft.com/office/drawing/2014/main" id="{0595FD15-7156-4E52-87B2-404D626063B5}"/>
+              </a:ext>
+            </a:extLst>
+          </p:cNvPr>
+          <p:cNvSpPr>
+            <a:spLocks xmlns:a="http://schemas.openxmlformats.org/drawingml/2006/main" noGrp="1"/>
+          </p:cNvSpPr>
+          <p:nvPr/>
+        </p:nvSpPr>
+        <p:spPr>
+          <a:xfrm xmlns:a="http://schemas.openxmlformats.org/drawingml/2006/main">
+            <a:off x="10134600" y="3181350"/>
+            <a:ext cx="2933700" cy="323850"/>
+          </a:xfrm>
+          <a:prstGeom xmlns:a="http://schemas.openxmlformats.org/drawingml/2006/main" prst="rect">
+            <a:avLst/>
+          </a:prstGeom>
+          <a:noFill xmlns:a="http://schemas.openxmlformats.org/drawingml/2006/main"/>
+          <a:ln xmlns:a="http://schemas.openxmlformats.org/drawingml/2006/main" w="0">
+            <a:noFill/>
+            <a:prstDash val="solid"/>
+          </a:ln>
+        </p:spPr>
+        <p:txBody>
+          <a:bodyPr xmlns:a="http://schemas.openxmlformats.org/drawingml/2006/main" wrap="square" lIns="0" tIns="0" rIns="0" bIns="0" anchor="ctr">
+            <a:noAutofit/>
+          </a:bodyPr>
+          <a:lstStyle xmlns:a="http://schemas.openxmlformats.org/drawingml/2006/main"/>
+          <a:p xmlns:a="http://schemas.openxmlformats.org/drawingml/2006/main">
+            <a:pPr algn="ctr">
+              <a:lnSpc>
+                <a:spcPct val="100000"/>
+              </a:lnSpc>
+              <a:buNone/>
+              <a:defRPr sz="1350" b="1">
+                <a:solidFill>
+                  <a:srgbClr val="00A2EB"/>
+                </a:solidFill>
+                <a:latin typeface="Calibri"/>
+                <a:ea typeface="Calibri"/>
+                <a:cs typeface="Calibri"/>
+              </a:defRPr>
+            </a:pPr>
+            <a:r>
+              <a:rPr sz="1800" b="1">
+                <a:solidFill>
+                  <a:srgbClr val="00A2EB"/>
+                </a:solidFill>
+                <a:latin typeface="Calibri"/>
+                <a:ea typeface="Calibri"/>
+                <a:cs typeface="Calibri"/>
+              </a:rPr>
+              <a:t>ACT + WRITE</a:t>
+            </a:r>
+          </a:p>
+        </p:txBody>
+      </p:sp>
+      <p:sp>
+        <p:nvSpPr>
+          <p:cNvPr id="12" name="">
+            <a:extLst xmlns:a="http://schemas.openxmlformats.org/drawingml/2006/main">
+              <a:ext uri="{FF2B5EF4-FFF2-40B4-BE49-F238E27FC236}">
+                <a16:creationId xmlns:a16="http://schemas.microsoft.com/office/drawing/2014/main" id="{39CEFAC4-B99C-4E5B-B744-4D0EEDB15B0B}"/>
+              </a:ext>
+            </a:extLst>
+          </p:cNvPr>
+          <p:cNvSpPr>
+            <a:spLocks xmlns:a="http://schemas.openxmlformats.org/drawingml/2006/main" noGrp="1"/>
+          </p:cNvSpPr>
+          <p:nvPr/>
+        </p:nvSpPr>
+        <p:spPr>
+          <a:xfrm xmlns:a="http://schemas.openxmlformats.org/drawingml/2006/main">
+            <a:off x="10134600" y="3638550"/>
+            <a:ext cx="2933700" cy="685800"/>
+          </a:xfrm>
+          <a:prstGeom xmlns:a="http://schemas.openxmlformats.org/drawingml/2006/main" prst="rect">
+            <a:avLst/>
+          </a:prstGeom>
+          <a:noFill xmlns:a="http://schemas.openxmlformats.org/drawingml/2006/main"/>
+          <a:ln xmlns:a="http://schemas.openxmlformats.org/drawingml/2006/main" w="0">
+            <a:noFill/>
+            <a:prstDash val="solid"/>
+          </a:ln>
+        </p:spPr>
+        <p:txBody>
+          <a:bodyPr xmlns:a="http://schemas.openxmlformats.org/drawingml/2006/main" wrap="square" lIns="0" tIns="0" rIns="0" bIns="0" anchor="ctr">
+            <a:normAutofit fontScale="71429"/>
+          </a:bodyPr>
+          <a:lstStyle xmlns:a="http://schemas.openxmlformats.org/drawingml/2006/main"/>
+          <a:p xmlns:a="http://schemas.openxmlformats.org/drawingml/2006/main">
+            <a:pPr algn="ctr">
+              <a:lnSpc>
+                <a:spcPct val="100000"/>
+              </a:lnSpc>
+              <a:buNone/>
+              <a:defRPr sz="2100" b="1">
+                <a:solidFill>
+                  <a:srgbClr val="FFFFFF"/>
+                </a:solidFill>
+                <a:latin typeface="Calibri"/>
+                <a:ea typeface="Calibri"/>
+                <a:cs typeface="Calibri"/>
+              </a:defRPr>
+            </a:pPr>
+            <a:r>
+              <a:rPr sz="2100" b="1">
+                <a:solidFill>
+                  <a:srgbClr val="FFFFFF"/>
+                </a:solidFill>
+                <a:latin typeface="Calibri"/>
+                <a:ea typeface="Calibri"/>
+                <a:cs typeface="Calibri"/>
+              </a:rPr>
+              <a:t>EXECUTOR calls tools</a:t>
+            </a:r>
+          </a:p>
+          <a:p xmlns:a="http://schemas.openxmlformats.org/drawingml/2006/main">
+            <a:pPr algn="ctr">
+              <a:lnSpc>
+                <a:spcPct val="100000"/>
+              </a:lnSpc>
+              <a:buNone/>
+              <a:defRPr sz="2100" b="1">
+                <a:solidFill>
+                  <a:srgbClr val="FFFFFF"/>
+                </a:solidFill>
+                <a:latin typeface="Calibri"/>
+                <a:ea typeface="Calibri"/>
+                <a:cs typeface="Calibri"/>
+              </a:defRPr>
+            </a:pPr>
+            <a:r>
+              <a:rPr sz="2100" b="1">
+                <a:solidFill>
+                  <a:srgbClr val="FFFFFF"/>
+                </a:solidFill>
+                <a:latin typeface="Calibri"/>
+                <a:ea typeface="Calibri"/>
+                <a:cs typeface="Calibri"/>
+              </a:rPr>
+              <a:t>REPORT WRITER cites evidence</a:t>
+            </a:r>
+          </a:p>
+        </p:txBody>
+      </p:sp>
+      <p:cxnSp>
+        <p:nvCxnSpPr>
+          <p:cNvPr id="348" name=""/>
+          <p:cNvCxnSpPr>
+            <a:stCxn xmlns:a="http://schemas.openxmlformats.org/drawingml/2006/main" id="3" idx="3"/>
+            <a:endCxn xmlns:a="http://schemas.openxmlformats.org/drawingml/2006/main" id="6" idx="1"/>
+          </p:cNvCxnSpPr>
+          <p:nvPr/>
+        </p:nvCxnSpPr>
+        <p:spPr>
+          <a:xfrm xmlns:a="http://schemas.openxmlformats.org/drawingml/2006/main">
+            <a:off x="3752850" y="3771900"/>
+            <a:ext cx="1409700" cy="0"/>
+          </a:xfrm>
+          <a:prstGeom xmlns:a="http://schemas.openxmlformats.org/drawingml/2006/main" prst="straightConnector1">
+            <a:avLst/>
+          </a:prstGeom>
+          <a:ln xmlns:a="http://schemas.openxmlformats.org/drawingml/2006/main" w="28575">
+            <a:solidFill>
+              <a:srgbClr val="F07D00"/>
+            </a:solidFill>
+            <a:prstDash val="solid"/>
+            <a:tailEnd type="triangle" w="med" len="med"/>
+          </a:ln>
+        </p:spPr>
+      </p:cxnSp>
+      <p:cxnSp>
+        <p:nvCxnSpPr>
+          <p:cNvPr id="349" name=""/>
+          <p:cNvCxnSpPr>
+            <a:stCxn xmlns:a="http://schemas.openxmlformats.org/drawingml/2006/main" id="6" idx="3"/>
+            <a:endCxn xmlns:a="http://schemas.openxmlformats.org/drawingml/2006/main" id="10" idx="1"/>
+          </p:cNvCxnSpPr>
+          <p:nvPr/>
+        </p:nvCxnSpPr>
+        <p:spPr>
+          <a:xfrm xmlns:a="http://schemas.openxmlformats.org/drawingml/2006/main" flipV="0">
+            <a:off x="8420100" y="3771900"/>
+            <a:ext cx="1409700" cy="0"/>
+          </a:xfrm>
+          <a:prstGeom xmlns:a="http://schemas.openxmlformats.org/drawingml/2006/main" prst="straightConnector1">
+            <a:avLst/>
+          </a:prstGeom>
+          <a:ln xmlns:a="http://schemas.openxmlformats.org/drawingml/2006/main" w="28575">
+            <a:solidFill>
+              <a:srgbClr val="F07D00"/>
+            </a:solidFill>
+            <a:prstDash val="solid"/>
+            <a:tailEnd type="triangle" w="med" len="med"/>
+          </a:ln>
+        </p:spPr>
+      </p:cxnSp>
+      <p:sp>
+        <p:nvSpPr>
+          <p:cNvPr id="15" name="">
+            <a:extLst xmlns:a="http://schemas.openxmlformats.org/drawingml/2006/main">
+              <a:ext uri="{FF2B5EF4-FFF2-40B4-BE49-F238E27FC236}">
+                <a16:creationId xmlns:a16="http://schemas.microsoft.com/office/drawing/2014/main" id="{FE1BEF3A-6A25-4B3F-8E60-6108148E5582}"/>
+              </a:ext>
+            </a:extLst>
+          </p:cNvPr>
+          <p:cNvSpPr>
+            <a:spLocks xmlns:a="http://schemas.openxmlformats.org/drawingml/2006/main" noGrp="1"/>
+          </p:cNvSpPr>
+          <p:nvPr/>
+        </p:nvSpPr>
+        <p:spPr>
+          <a:xfrm xmlns:a="http://schemas.openxmlformats.org/drawingml/2006/main">
+            <a:off x="1600200" y="5467350"/>
+            <a:ext cx="12039600" cy="1123950"/>
+          </a:xfrm>
+          <a:prstGeom xmlns:a="http://schemas.openxmlformats.org/drawingml/2006/main" prst="roundRect">
+            <a:avLst>
+              <a:gd name="adj" fmla="val 8475"/>
             </a:avLst>
           </a:prstGeom>
           <a:solidFill xmlns:a="http://schemas.openxmlformats.org/drawingml/2006/main">
@@ -7644,22 +8176,22 @@
       </p:sp>
       <p:sp>
         <p:nvSpPr>
-          <p:cNvPr id="8" name="">
-            <a:extLst xmlns:a="http://schemas.openxmlformats.org/drawingml/2006/main">
-              <a:ext uri="{FF2B5EF4-FFF2-40B4-BE49-F238E27FC236}">
-                <a16:creationId xmlns:a16="http://schemas.microsoft.com/office/drawing/2014/main" id="{18679081-8A68-4B7E-9199-340CF95714DE}"/>
-              </a:ext>
-            </a:extLst>
-          </p:cNvPr>
-          <p:cNvSpPr>
-            <a:spLocks xmlns:a="http://schemas.openxmlformats.org/drawingml/2006/main" noGrp="1"/>
-          </p:cNvSpPr>
-          <p:nvPr/>
-        </p:nvSpPr>
-        <p:spPr>
-          <a:xfrm xmlns:a="http://schemas.openxmlformats.org/drawingml/2006/main">
-            <a:off x="4000500" y="3295650"/>
-            <a:ext cx="514350" cy="285750"/>
+          <p:cNvPr id="16" name="">
+            <a:extLst xmlns:a="http://schemas.openxmlformats.org/drawingml/2006/main">
+              <a:ext uri="{FF2B5EF4-FFF2-40B4-BE49-F238E27FC236}">
+                <a16:creationId xmlns:a16="http://schemas.microsoft.com/office/drawing/2014/main" id="{DFE4947E-2E2C-4D5A-B088-DFED206E71BC}"/>
+              </a:ext>
+            </a:extLst>
+          </p:cNvPr>
+          <p:cNvSpPr>
+            <a:spLocks xmlns:a="http://schemas.openxmlformats.org/drawingml/2006/main" noGrp="1"/>
+          </p:cNvSpPr>
+          <p:nvPr/>
+        </p:nvSpPr>
+        <p:spPr>
+          <a:xfrm xmlns:a="http://schemas.openxmlformats.org/drawingml/2006/main">
+            <a:off x="1943100" y="5638800"/>
+            <a:ext cx="2476500" cy="285750"/>
           </a:xfrm>
           <a:prstGeom xmlns:a="http://schemas.openxmlformats.org/drawingml/2006/main" prst="rect">
             <a:avLst/>
@@ -7681,9 +8213,9 @@
                 <a:spcPct val="100000"/>
               </a:lnSpc>
               <a:buNone/>
-              <a:defRPr sz="1350" b="1">
-                <a:solidFill>
-                  <a:srgbClr val="00A2EB"/>
+              <a:defRPr sz="1275" b="1">
+                <a:solidFill>
+                  <a:srgbClr val="F07D00"/>
                 </a:solidFill>
                 <a:latin typeface="Calibri"/>
                 <a:ea typeface="Calibri"/>
@@ -7693,35 +8225,35 @@
             <a:r>
               <a:rPr sz="1800" b="1">
                 <a:solidFill>
-                  <a:srgbClr val="00A2EB"/>
-                </a:solidFill>
-                <a:latin typeface="Calibri"/>
-                <a:ea typeface="Calibri"/>
-                <a:cs typeface="Calibri"/>
-              </a:rPr>
-              <a:t>02</a:t>
-            </a:r>
-          </a:p>
-        </p:txBody>
-      </p:sp>
-      <p:sp>
-        <p:nvSpPr>
-          <p:cNvPr id="9" name="">
-            <a:extLst xmlns:a="http://schemas.openxmlformats.org/drawingml/2006/main">
-              <a:ext uri="{FF2B5EF4-FFF2-40B4-BE49-F238E27FC236}">
-                <a16:creationId xmlns:a16="http://schemas.microsoft.com/office/drawing/2014/main" id="{ED095E54-44DC-4092-9EB7-0C81E4B47710}"/>
-              </a:ext>
-            </a:extLst>
-          </p:cNvPr>
-          <p:cNvSpPr>
-            <a:spLocks xmlns:a="http://schemas.openxmlformats.org/drawingml/2006/main" noGrp="1"/>
-          </p:cNvSpPr>
-          <p:nvPr/>
-        </p:nvSpPr>
-        <p:spPr>
-          <a:xfrm xmlns:a="http://schemas.openxmlformats.org/drawingml/2006/main">
-            <a:off x="3924300" y="3752850"/>
-            <a:ext cx="2019300" cy="685800"/>
+                  <a:srgbClr val="F07D00"/>
+                </a:solidFill>
+                <a:latin typeface="Calibri"/>
+                <a:ea typeface="Calibri"/>
+                <a:cs typeface="Calibri"/>
+              </a:rPr>
+              <a:t>KEEP</a:t>
+            </a:r>
+          </a:p>
+        </p:txBody>
+      </p:sp>
+      <p:sp>
+        <p:nvSpPr>
+          <p:cNvPr id="17" name="">
+            <a:extLst xmlns:a="http://schemas.openxmlformats.org/drawingml/2006/main">
+              <a:ext uri="{FF2B5EF4-FFF2-40B4-BE49-F238E27FC236}">
+                <a16:creationId xmlns:a16="http://schemas.microsoft.com/office/drawing/2014/main" id="{DC1A217F-7E45-4462-994A-E1A7947A47FC}"/>
+              </a:ext>
+            </a:extLst>
+          </p:cNvPr>
+          <p:cNvSpPr>
+            <a:spLocks xmlns:a="http://schemas.openxmlformats.org/drawingml/2006/main" noGrp="1"/>
+          </p:cNvSpPr>
+          <p:nvPr/>
+        </p:nvSpPr>
+        <p:spPr>
+          <a:xfrm xmlns:a="http://schemas.openxmlformats.org/drawingml/2006/main">
+            <a:off x="1943100" y="5962650"/>
+            <a:ext cx="4953000" cy="400050"/>
           </a:xfrm>
           <a:prstGeom xmlns:a="http://schemas.openxmlformats.org/drawingml/2006/main" prst="rect">
             <a:avLst/>
@@ -7743,7 +8275,7 @@
                 <a:spcPct val="100000"/>
               </a:lnSpc>
               <a:buNone/>
-              <a:defRPr sz="1950" b="1">
+              <a:defRPr sz="1650" b="1">
                 <a:solidFill>
                   <a:srgbClr val="051C2A"/>
                 </a:solidFill>
@@ -7753,7 +8285,7 @@
               </a:defRPr>
             </a:pPr>
             <a:r>
-              <a:rPr sz="1950" b="1">
+              <a:rPr sz="1650" b="1">
                 <a:solidFill>
                   <a:srgbClr val="051C2A"/>
                 </a:solidFill>
@@ -7761,322 +8293,37 @@
                 <a:ea typeface="Calibri"/>
                 <a:cs typeface="Calibri"/>
               </a:rPr>
-              <a:t>EXECUTOR</a:t>
-            </a:r>
-          </a:p>
-        </p:txBody>
-      </p:sp>
-      <p:sp>
-        <p:nvSpPr>
-          <p:cNvPr id="10" name="">
-            <a:extLst xmlns:a="http://schemas.openxmlformats.org/drawingml/2006/main">
-              <a:ext uri="{FF2B5EF4-FFF2-40B4-BE49-F238E27FC236}">
-                <a16:creationId xmlns:a16="http://schemas.microsoft.com/office/drawing/2014/main" id="{4DB65E8E-6BA9-40DB-99F9-46D3397B13A3}"/>
-              </a:ext>
-            </a:extLst>
-          </p:cNvPr>
-          <p:cNvSpPr>
-            <a:spLocks xmlns:a="http://schemas.openxmlformats.org/drawingml/2006/main" noGrp="1"/>
-          </p:cNvSpPr>
-          <p:nvPr/>
-        </p:nvSpPr>
-        <p:spPr>
-          <a:xfrm xmlns:a="http://schemas.openxmlformats.org/drawingml/2006/main">
-            <a:off x="4000500" y="4610100"/>
-            <a:ext cx="1866900" cy="514350"/>
-          </a:xfrm>
-          <a:prstGeom xmlns:a="http://schemas.openxmlformats.org/drawingml/2006/main" prst="rect">
-            <a:avLst/>
-          </a:prstGeom>
-          <a:noFill xmlns:a="http://schemas.openxmlformats.org/drawingml/2006/main"/>
-          <a:ln xmlns:a="http://schemas.openxmlformats.org/drawingml/2006/main" w="0">
-            <a:noFill/>
-            <a:prstDash val="solid"/>
-          </a:ln>
-        </p:spPr>
-        <p:txBody>
-          <a:bodyPr xmlns:a="http://schemas.openxmlformats.org/drawingml/2006/main" wrap="square" lIns="0" tIns="0" rIns="0" bIns="0" anchor="ctr">
-            <a:normAutofit fontScale="100000"/>
-          </a:bodyPr>
-          <a:lstStyle xmlns:a="http://schemas.openxmlformats.org/drawingml/2006/main"/>
-          <a:p xmlns:a="http://schemas.openxmlformats.org/drawingml/2006/main">
-            <a:pPr algn="l">
-              <a:lnSpc>
-                <a:spcPct val="100000"/>
-              </a:lnSpc>
-              <a:buNone/>
-              <a:defRPr sz="1200" b="0">
-                <a:solidFill>
-                  <a:srgbClr val="1F40CB"/>
-                </a:solidFill>
-                <a:latin typeface="Calibri"/>
-                <a:ea typeface="Calibri"/>
-                <a:cs typeface="Calibri"/>
-              </a:defRPr>
-            </a:pPr>
-            <a:r>
-              <a:rPr sz="1200" b="0">
-                <a:solidFill>
-                  <a:srgbClr val="1F40CB"/>
-                </a:solidFill>
-                <a:latin typeface="Calibri"/>
-                <a:ea typeface="Calibri"/>
-                <a:cs typeface="Calibri"/>
-              </a:rPr>
-              <a:t>runs one step</a:t>
-            </a:r>
-          </a:p>
-        </p:txBody>
-      </p:sp>
-      <p:sp>
-        <p:nvSpPr>
-          <p:cNvPr id="11" name="ingestion-3">
-            <a:extLst xmlns:a="http://schemas.openxmlformats.org/drawingml/2006/main">
-              <a:ext uri="{FF2B5EF4-FFF2-40B4-BE49-F238E27FC236}">
-                <a16:creationId xmlns:a16="http://schemas.microsoft.com/office/drawing/2014/main" id="{D4342A97-3791-461F-A305-9671DA4948CE}"/>
-              </a:ext>
-            </a:extLst>
-          </p:cNvPr>
-          <p:cNvSpPr>
-            <a:spLocks xmlns:a="http://schemas.openxmlformats.org/drawingml/2006/main" noGrp="1"/>
-          </p:cNvSpPr>
-          <p:nvPr/>
-        </p:nvSpPr>
-        <p:spPr>
-          <a:xfrm xmlns:a="http://schemas.openxmlformats.org/drawingml/2006/main">
-            <a:off x="6629400" y="3086100"/>
-            <a:ext cx="2247900" cy="2266950"/>
-          </a:xfrm>
-          <a:prstGeom xmlns:a="http://schemas.openxmlformats.org/drawingml/2006/main" prst="roundRect">
-            <a:avLst>
-              <a:gd name="adj" fmla="val 5085"/>
-            </a:avLst>
+              <a:t>one shared host state</a:t>
+            </a:r>
+          </a:p>
+        </p:txBody>
+      </p:sp>
+      <p:sp>
+        <p:nvSpPr>
+          <p:cNvPr id="18" name="">
+            <a:extLst xmlns:a="http://schemas.openxmlformats.org/drawingml/2006/main">
+              <a:ext uri="{FF2B5EF4-FFF2-40B4-BE49-F238E27FC236}">
+                <a16:creationId xmlns:a16="http://schemas.microsoft.com/office/drawing/2014/main" id="{4B74CAF0-D3F9-408B-B959-2864FA7108BD}"/>
+              </a:ext>
+            </a:extLst>
+          </p:cNvPr>
+          <p:cNvSpPr>
+            <a:spLocks xmlns:a="http://schemas.openxmlformats.org/drawingml/2006/main" noGrp="1"/>
+          </p:cNvSpPr>
+          <p:nvPr/>
+        </p:nvSpPr>
+        <p:spPr>
+          <a:xfrm xmlns:a="http://schemas.openxmlformats.org/drawingml/2006/main">
+            <a:off x="7486650" y="5638800"/>
+            <a:ext cx="28575" cy="742950"/>
+          </a:xfrm>
+          <a:prstGeom xmlns:a="http://schemas.openxmlformats.org/drawingml/2006/main" prst="rect">
+            <a:avLst/>
           </a:prstGeom>
           <a:solidFill xmlns:a="http://schemas.openxmlformats.org/drawingml/2006/main">
-            <a:srgbClr val="062433"/>
+            <a:srgbClr val="E4E7E9"/>
           </a:solidFill>
-          <a:ln xmlns:a="http://schemas.openxmlformats.org/drawingml/2006/main" w="9525">
-            <a:solidFill>
-              <a:srgbClr val="062433"/>
-            </a:solidFill>
-            <a:prstDash val="solid"/>
-          </a:ln>
-        </p:spPr>
-      </p:sp>
-      <p:sp>
-        <p:nvSpPr>
-          <p:cNvPr id="12" name="">
-            <a:extLst xmlns:a="http://schemas.openxmlformats.org/drawingml/2006/main">
-              <a:ext uri="{FF2B5EF4-FFF2-40B4-BE49-F238E27FC236}">
-                <a16:creationId xmlns:a16="http://schemas.microsoft.com/office/drawing/2014/main" id="{64E49A95-2D88-4387-8BD5-FA749ABD0960}"/>
-              </a:ext>
-            </a:extLst>
-          </p:cNvPr>
-          <p:cNvSpPr>
-            <a:spLocks xmlns:a="http://schemas.openxmlformats.org/drawingml/2006/main" noGrp="1"/>
-          </p:cNvSpPr>
-          <p:nvPr/>
-        </p:nvSpPr>
-        <p:spPr>
-          <a:xfrm xmlns:a="http://schemas.openxmlformats.org/drawingml/2006/main">
-            <a:off x="6819900" y="3295650"/>
-            <a:ext cx="514350" cy="285750"/>
-          </a:xfrm>
-          <a:prstGeom xmlns:a="http://schemas.openxmlformats.org/drawingml/2006/main" prst="rect">
-            <a:avLst/>
-          </a:prstGeom>
-          <a:noFill xmlns:a="http://schemas.openxmlformats.org/drawingml/2006/main"/>
-          <a:ln xmlns:a="http://schemas.openxmlformats.org/drawingml/2006/main" w="0">
-            <a:noFill/>
-            <a:prstDash val="solid"/>
-          </a:ln>
-        </p:spPr>
-        <p:txBody>
-          <a:bodyPr xmlns:a="http://schemas.openxmlformats.org/drawingml/2006/main" wrap="square" lIns="0" tIns="0" rIns="0" bIns="0" anchor="ctr">
-            <a:noAutofit/>
-          </a:bodyPr>
-          <a:lstStyle xmlns:a="http://schemas.openxmlformats.org/drawingml/2006/main"/>
-          <a:p xmlns:a="http://schemas.openxmlformats.org/drawingml/2006/main">
-            <a:pPr algn="l">
-              <a:lnSpc>
-                <a:spcPct val="100000"/>
-              </a:lnSpc>
-              <a:buNone/>
-              <a:defRPr sz="1350" b="1">
-                <a:solidFill>
-                  <a:srgbClr val="00A2EB"/>
-                </a:solidFill>
-                <a:latin typeface="Calibri"/>
-                <a:ea typeface="Calibri"/>
-                <a:cs typeface="Calibri"/>
-              </a:defRPr>
-            </a:pPr>
-            <a:r>
-              <a:rPr sz="1800" b="1">
-                <a:solidFill>
-                  <a:srgbClr val="00A2EB"/>
-                </a:solidFill>
-                <a:latin typeface="Calibri"/>
-                <a:ea typeface="Calibri"/>
-                <a:cs typeface="Calibri"/>
-              </a:rPr>
-              <a:t>03</a:t>
-            </a:r>
-          </a:p>
-        </p:txBody>
-      </p:sp>
-      <p:sp>
-        <p:nvSpPr>
-          <p:cNvPr id="13" name="">
-            <a:extLst xmlns:a="http://schemas.openxmlformats.org/drawingml/2006/main">
-              <a:ext uri="{FF2B5EF4-FFF2-40B4-BE49-F238E27FC236}">
-                <a16:creationId xmlns:a16="http://schemas.microsoft.com/office/drawing/2014/main" id="{572D3874-F985-4CD0-BBFF-D59F5B7B32BE}"/>
-              </a:ext>
-            </a:extLst>
-          </p:cNvPr>
-          <p:cNvSpPr>
-            <a:spLocks xmlns:a="http://schemas.openxmlformats.org/drawingml/2006/main" noGrp="1"/>
-          </p:cNvSpPr>
-          <p:nvPr/>
-        </p:nvSpPr>
-        <p:spPr>
-          <a:xfrm xmlns:a="http://schemas.openxmlformats.org/drawingml/2006/main">
-            <a:off x="6743700" y="3752850"/>
-            <a:ext cx="2019300" cy="685800"/>
-          </a:xfrm>
-          <a:prstGeom xmlns:a="http://schemas.openxmlformats.org/drawingml/2006/main" prst="rect">
-            <a:avLst/>
-          </a:prstGeom>
-          <a:noFill xmlns:a="http://schemas.openxmlformats.org/drawingml/2006/main"/>
-          <a:ln xmlns:a="http://schemas.openxmlformats.org/drawingml/2006/main" w="0">
-            <a:noFill/>
-            <a:prstDash val="solid"/>
-          </a:ln>
-        </p:spPr>
-        <p:txBody>
-          <a:bodyPr xmlns:a="http://schemas.openxmlformats.org/drawingml/2006/main" wrap="square" lIns="0" tIns="0" rIns="0" bIns="0" anchor="ctr">
-            <a:noAutofit/>
-          </a:bodyPr>
-          <a:lstStyle xmlns:a="http://schemas.openxmlformats.org/drawingml/2006/main"/>
-          <a:p xmlns:a="http://schemas.openxmlformats.org/drawingml/2006/main">
-            <a:pPr algn="l">
-              <a:lnSpc>
-                <a:spcPct val="100000"/>
-              </a:lnSpc>
-              <a:buNone/>
-              <a:defRPr sz="1650" b="1">
-                <a:solidFill>
-                  <a:srgbClr val="FFFFFF"/>
-                </a:solidFill>
-                <a:latin typeface="Calibri"/>
-                <a:ea typeface="Calibri"/>
-                <a:cs typeface="Calibri"/>
-              </a:defRPr>
-            </a:pPr>
-            <a:r>
-              <a:rPr sz="1800" b="1">
-                <a:solidFill>
-                  <a:srgbClr val="FFFFFF"/>
-                </a:solidFill>
-                <a:latin typeface="Calibri"/>
-                <a:ea typeface="Calibri"/>
-                <a:cs typeface="Calibri"/>
-              </a:rPr>
-              <a:t>REPLANNER</a:t>
-            </a:r>
-          </a:p>
-        </p:txBody>
-      </p:sp>
-      <p:sp>
-        <p:nvSpPr>
-          <p:cNvPr id="14" name="">
-            <a:extLst xmlns:a="http://schemas.openxmlformats.org/drawingml/2006/main">
-              <a:ext uri="{FF2B5EF4-FFF2-40B4-BE49-F238E27FC236}">
-                <a16:creationId xmlns:a16="http://schemas.microsoft.com/office/drawing/2014/main" id="{9599AF29-91DE-47C0-8189-B0778BB52724}"/>
-              </a:ext>
-            </a:extLst>
-          </p:cNvPr>
-          <p:cNvSpPr>
-            <a:spLocks xmlns:a="http://schemas.openxmlformats.org/drawingml/2006/main" noGrp="1"/>
-          </p:cNvSpPr>
-          <p:nvPr/>
-        </p:nvSpPr>
-        <p:spPr>
-          <a:xfrm xmlns:a="http://schemas.openxmlformats.org/drawingml/2006/main">
-            <a:off x="6819900" y="4610100"/>
-            <a:ext cx="1866900" cy="514350"/>
-          </a:xfrm>
-          <a:prstGeom xmlns:a="http://schemas.openxmlformats.org/drawingml/2006/main" prst="rect">
-            <a:avLst/>
-          </a:prstGeom>
-          <a:noFill xmlns:a="http://schemas.openxmlformats.org/drawingml/2006/main"/>
-          <a:ln xmlns:a="http://schemas.openxmlformats.org/drawingml/2006/main" w="0">
-            <a:noFill/>
-            <a:prstDash val="solid"/>
-          </a:ln>
-        </p:spPr>
-        <p:txBody>
-          <a:bodyPr xmlns:a="http://schemas.openxmlformats.org/drawingml/2006/main" wrap="square" lIns="0" tIns="0" rIns="0" bIns="0" anchor="ctr">
-            <a:normAutofit fontScale="100000"/>
-          </a:bodyPr>
-          <a:lstStyle xmlns:a="http://schemas.openxmlformats.org/drawingml/2006/main"/>
-          <a:p xmlns:a="http://schemas.openxmlformats.org/drawingml/2006/main">
-            <a:pPr algn="l">
-              <a:lnSpc>
-                <a:spcPct val="100000"/>
-              </a:lnSpc>
-              <a:buNone/>
-              <a:defRPr sz="1200" b="0">
-                <a:solidFill>
-                  <a:srgbClr val="00A2EB"/>
-                </a:solidFill>
-                <a:latin typeface="Calibri"/>
-                <a:ea typeface="Calibri"/>
-                <a:cs typeface="Calibri"/>
-              </a:defRPr>
-            </a:pPr>
-            <a:r>
-              <a:rPr sz="1200" b="0">
-                <a:solidFill>
-                  <a:srgbClr val="00A2EB"/>
-                </a:solidFill>
-                <a:latin typeface="Calibri"/>
-                <a:ea typeface="Calibri"/>
-                <a:cs typeface="Calibri"/>
-              </a:rPr>
-              <a:t>replaces tail</a:t>
-            </a:r>
-          </a:p>
-        </p:txBody>
-      </p:sp>
-      <p:sp>
-        <p:nvSpPr>
-          <p:cNvPr id="15" name="ingestion-4">
-            <a:extLst xmlns:a="http://schemas.openxmlformats.org/drawingml/2006/main">
-              <a:ext uri="{FF2B5EF4-FFF2-40B4-BE49-F238E27FC236}">
-                <a16:creationId xmlns:a16="http://schemas.microsoft.com/office/drawing/2014/main" id="{7952DE37-BD86-481C-A575-8709971DD74E}"/>
-              </a:ext>
-            </a:extLst>
-          </p:cNvPr>
-          <p:cNvSpPr>
-            <a:spLocks xmlns:a="http://schemas.openxmlformats.org/drawingml/2006/main" noGrp="1"/>
-          </p:cNvSpPr>
-          <p:nvPr/>
-        </p:nvSpPr>
-        <p:spPr>
-          <a:xfrm xmlns:a="http://schemas.openxmlformats.org/drawingml/2006/main">
-            <a:off x="9448800" y="3086100"/>
-            <a:ext cx="2247900" cy="2266950"/>
-          </a:xfrm>
-          <a:prstGeom xmlns:a="http://schemas.openxmlformats.org/drawingml/2006/main" prst="roundRect">
-            <a:avLst>
-              <a:gd name="adj" fmla="val 5085"/>
-            </a:avLst>
-          </a:prstGeom>
-          <a:solidFill xmlns:a="http://schemas.openxmlformats.org/drawingml/2006/main">
-            <a:srgbClr val="FFFFFF"/>
-          </a:solidFill>
-          <a:ln xmlns:a="http://schemas.openxmlformats.org/drawingml/2006/main" w="9525">
+          <a:ln xmlns:a="http://schemas.openxmlformats.org/drawingml/2006/main" w="0">
             <a:solidFill>
               <a:srgbClr val="E4E7E9"/>
             </a:solidFill>
@@ -8086,22 +8333,22 @@
       </p:sp>
       <p:sp>
         <p:nvSpPr>
-          <p:cNvPr id="16" name="">
-            <a:extLst xmlns:a="http://schemas.openxmlformats.org/drawingml/2006/main">
-              <a:ext uri="{FF2B5EF4-FFF2-40B4-BE49-F238E27FC236}">
-                <a16:creationId xmlns:a16="http://schemas.microsoft.com/office/drawing/2014/main" id="{62EC2EC9-18A1-4F72-A64D-AF536DDC8F61}"/>
-              </a:ext>
-            </a:extLst>
-          </p:cNvPr>
-          <p:cNvSpPr>
-            <a:spLocks xmlns:a="http://schemas.openxmlformats.org/drawingml/2006/main" noGrp="1"/>
-          </p:cNvSpPr>
-          <p:nvPr/>
-        </p:nvSpPr>
-        <p:spPr>
-          <a:xfrm xmlns:a="http://schemas.openxmlformats.org/drawingml/2006/main">
-            <a:off x="9639300" y="3295650"/>
-            <a:ext cx="514350" cy="285750"/>
+          <p:cNvPr id="19" name="">
+            <a:extLst xmlns:a="http://schemas.openxmlformats.org/drawingml/2006/main">
+              <a:ext uri="{FF2B5EF4-FFF2-40B4-BE49-F238E27FC236}">
+                <a16:creationId xmlns:a16="http://schemas.microsoft.com/office/drawing/2014/main" id="{F6C058E3-0326-4715-852F-1F8B32F61FB5}"/>
+              </a:ext>
+            </a:extLst>
+          </p:cNvPr>
+          <p:cNvSpPr>
+            <a:spLocks xmlns:a="http://schemas.openxmlformats.org/drawingml/2006/main" noGrp="1"/>
+          </p:cNvSpPr>
+          <p:nvPr/>
+        </p:nvSpPr>
+        <p:spPr>
+          <a:xfrm xmlns:a="http://schemas.openxmlformats.org/drawingml/2006/main">
+            <a:off x="7867650" y="5638800"/>
+            <a:ext cx="3143250" cy="285750"/>
           </a:xfrm>
           <a:prstGeom xmlns:a="http://schemas.openxmlformats.org/drawingml/2006/main" prst="rect">
             <a:avLst/>
@@ -8123,7 +8370,7 @@
                 <a:spcPct val="100000"/>
               </a:lnSpc>
               <a:buNone/>
-              <a:defRPr sz="1350" b="1">
+              <a:defRPr sz="1275" b="1">
                 <a:solidFill>
                   <a:srgbClr val="00A2EB"/>
                 </a:solidFill>
@@ -8141,29 +8388,29 @@
                 <a:ea typeface="Calibri"/>
                 <a:cs typeface="Calibri"/>
               </a:rPr>
-              <a:t>04</a:t>
-            </a:r>
-          </a:p>
-        </p:txBody>
-      </p:sp>
-      <p:sp>
-        <p:nvSpPr>
-          <p:cNvPr id="17" name="">
-            <a:extLst xmlns:a="http://schemas.openxmlformats.org/drawingml/2006/main">
-              <a:ext uri="{FF2B5EF4-FFF2-40B4-BE49-F238E27FC236}">
-                <a16:creationId xmlns:a16="http://schemas.microsoft.com/office/drawing/2014/main" id="{8540FD5A-1C0F-4BE1-B862-685F20D0F43C}"/>
-              </a:ext>
-            </a:extLst>
-          </p:cNvPr>
-          <p:cNvSpPr>
-            <a:spLocks xmlns:a="http://schemas.openxmlformats.org/drawingml/2006/main" noGrp="1"/>
-          </p:cNvSpPr>
-          <p:nvPr/>
-        </p:nvSpPr>
-        <p:spPr>
-          <a:xfrm xmlns:a="http://schemas.openxmlformats.org/drawingml/2006/main">
-            <a:off x="9563100" y="3752850"/>
-            <a:ext cx="2019300" cy="685800"/>
+              <a:t>NODES SHARE STATE</a:t>
+            </a:r>
+          </a:p>
+        </p:txBody>
+      </p:sp>
+      <p:sp>
+        <p:nvSpPr>
+          <p:cNvPr id="20" name="">
+            <a:extLst xmlns:a="http://schemas.openxmlformats.org/drawingml/2006/main">
+              <a:ext uri="{FF2B5EF4-FFF2-40B4-BE49-F238E27FC236}">
+                <a16:creationId xmlns:a16="http://schemas.microsoft.com/office/drawing/2014/main" id="{0AA9B25E-ADFB-4067-BF4C-46A5AE9FE838}"/>
+              </a:ext>
+            </a:extLst>
+          </p:cNvPr>
+          <p:cNvSpPr>
+            <a:spLocks xmlns:a="http://schemas.openxmlformats.org/drawingml/2006/main" noGrp="1"/>
+          </p:cNvSpPr>
+          <p:nvPr/>
+        </p:nvSpPr>
+        <p:spPr>
+          <a:xfrm xmlns:a="http://schemas.openxmlformats.org/drawingml/2006/main">
+            <a:off x="7867650" y="5962650"/>
+            <a:ext cx="5143500" cy="400050"/>
           </a:xfrm>
           <a:prstGeom xmlns:a="http://schemas.openxmlformats.org/drawingml/2006/main" prst="rect">
             <a:avLst/>
@@ -8185,7 +8432,7 @@
                 <a:spcPct val="100000"/>
               </a:lnSpc>
               <a:buNone/>
-              <a:defRPr sz="1950" b="1">
+              <a:defRPr sz="1650" b="1">
                 <a:solidFill>
                   <a:srgbClr val="051C2A"/>
                 </a:solidFill>
@@ -8195,7 +8442,7 @@
               </a:defRPr>
             </a:pPr>
             <a:r>
-              <a:rPr sz="1950" b="1">
+              <a:rPr sz="1650" b="1">
                 <a:solidFill>
                   <a:srgbClr val="051C2A"/>
                 </a:solidFill>
@@ -8203,29 +8450,91 @@
                 <a:ea typeface="Calibri"/>
                 <a:cs typeface="Calibri"/>
               </a:rPr>
-              <a:t>REPORT</a:t>
-            </a:r>
-          </a:p>
-        </p:txBody>
-      </p:sp>
-      <p:sp>
-        <p:nvSpPr>
-          <p:cNvPr id="18" name="">
-            <a:extLst xmlns:a="http://schemas.openxmlformats.org/drawingml/2006/main">
-              <a:ext uri="{FF2B5EF4-FFF2-40B4-BE49-F238E27FC236}">
-                <a16:creationId xmlns:a16="http://schemas.microsoft.com/office/drawing/2014/main" id="{67E52B70-645C-40F7-B0DE-1D1D177875CC}"/>
-              </a:ext>
-            </a:extLst>
-          </p:cNvPr>
-          <p:cNvSpPr>
-            <a:spLocks xmlns:a="http://schemas.openxmlformats.org/drawingml/2006/main" noGrp="1"/>
-          </p:cNvSpPr>
-          <p:nvPr/>
-        </p:nvSpPr>
-        <p:spPr>
-          <a:xfrm xmlns:a="http://schemas.openxmlformats.org/drawingml/2006/main">
-            <a:off x="9639300" y="4610100"/>
-            <a:ext cx="1866900" cy="514350"/>
+              <a:t>state is not a terminal role</a:t>
+            </a:r>
+          </a:p>
+        </p:txBody>
+      </p:sp>
+      <p:sp>
+        <p:nvSpPr>
+          <p:cNvPr id="21" name="">
+            <a:extLst xmlns:a="http://schemas.openxmlformats.org/drawingml/2006/main">
+              <a:ext uri="{FF2B5EF4-FFF2-40B4-BE49-F238E27FC236}">
+                <a16:creationId xmlns:a16="http://schemas.microsoft.com/office/drawing/2014/main" id="{BCAA4B4E-BD27-48A6-A4E1-ACF33C620C4D}"/>
+              </a:ext>
+            </a:extLst>
+          </p:cNvPr>
+          <p:cNvSpPr>
+            <a:spLocks xmlns:a="http://schemas.openxmlformats.org/drawingml/2006/main" noGrp="1"/>
+          </p:cNvSpPr>
+          <p:nvPr/>
+        </p:nvSpPr>
+        <p:spPr>
+          <a:xfrm xmlns:a="http://schemas.openxmlformats.org/drawingml/2006/main">
+            <a:off x="1028700" y="7086600"/>
+            <a:ext cx="1524000" cy="323850"/>
+          </a:xfrm>
+          <a:prstGeom xmlns:a="http://schemas.openxmlformats.org/drawingml/2006/main" prst="rect">
+            <a:avLst/>
+          </a:prstGeom>
+          <a:noFill xmlns:a="http://schemas.openxmlformats.org/drawingml/2006/main"/>
+          <a:ln xmlns:a="http://schemas.openxmlformats.org/drawingml/2006/main" w="0">
+            <a:noFill/>
+            <a:prstDash val="solid"/>
+          </a:ln>
+        </p:spPr>
+        <p:txBody>
+          <a:bodyPr xmlns:a="http://schemas.openxmlformats.org/drawingml/2006/main" wrap="square" lIns="0" tIns="0" rIns="0" bIns="0" anchor="ctr">
+            <a:noAutofit/>
+          </a:bodyPr>
+          <a:lstStyle xmlns:a="http://schemas.openxmlformats.org/drawingml/2006/main"/>
+          <a:p xmlns:a="http://schemas.openxmlformats.org/drawingml/2006/main">
+            <a:pPr algn="l">
+              <a:lnSpc>
+                <a:spcPct val="100000"/>
+              </a:lnSpc>
+              <a:buNone/>
+              <a:defRPr sz="1350" b="1">
+                <a:solidFill>
+                  <a:srgbClr val="F07D00"/>
+                </a:solidFill>
+                <a:latin typeface="Calibri"/>
+                <a:ea typeface="Calibri"/>
+                <a:cs typeface="Calibri"/>
+              </a:defRPr>
+            </a:pPr>
+            <a:r>
+              <a:rPr sz="1800" b="1">
+                <a:solidFill>
+                  <a:srgbClr val="F07D00"/>
+                </a:solidFill>
+                <a:latin typeface="Calibri"/>
+                <a:ea typeface="Calibri"/>
+                <a:cs typeface="Calibri"/>
+              </a:rPr>
+              <a:t>HOST CONTROL</a:t>
+            </a:r>
+          </a:p>
+        </p:txBody>
+      </p:sp>
+      <p:sp>
+        <p:nvSpPr>
+          <p:cNvPr id="22" name="">
+            <a:extLst xmlns:a="http://schemas.openxmlformats.org/drawingml/2006/main">
+              <a:ext uri="{FF2B5EF4-FFF2-40B4-BE49-F238E27FC236}">
+                <a16:creationId xmlns:a16="http://schemas.microsoft.com/office/drawing/2014/main" id="{539B97AA-C4C9-4A8D-997E-C7AD0F311AD6}"/>
+              </a:ext>
+            </a:extLst>
+          </p:cNvPr>
+          <p:cNvSpPr>
+            <a:spLocks xmlns:a="http://schemas.openxmlformats.org/drawingml/2006/main" noGrp="1"/>
+          </p:cNvSpPr>
+          <p:nvPr/>
+        </p:nvSpPr>
+        <p:spPr>
+          <a:xfrm xmlns:a="http://schemas.openxmlformats.org/drawingml/2006/main">
+            <a:off x="2705100" y="6991350"/>
+            <a:ext cx="11410950" cy="476250"/>
           </a:xfrm>
           <a:prstGeom xmlns:a="http://schemas.openxmlformats.org/drawingml/2006/main" prst="rect">
             <a:avLst/>
@@ -8247,7 +8556,7 @@
                 <a:spcPct val="100000"/>
               </a:lnSpc>
               <a:buNone/>
-              <a:defRPr sz="1200" b="0">
+              <a:defRPr sz="1875" b="1">
                 <a:solidFill>
                   <a:srgbClr val="1F40CB"/>
                 </a:solidFill>
@@ -8257,7 +8566,7 @@
               </a:defRPr>
             </a:pPr>
             <a:r>
-              <a:rPr sz="1200" b="0">
+              <a:rPr sz="1875" b="1">
                 <a:solidFill>
                   <a:srgbClr val="1F40CB"/>
                 </a:solidFill>
@@ -8265,528 +8574,17 @@
                 <a:ea typeface="Calibri"/>
                 <a:cs typeface="Calibri"/>
               </a:rPr>
-              <a:t>writes briefing</a:t>
-            </a:r>
-          </a:p>
-        </p:txBody>
-      </p:sp>
-      <p:sp>
-        <p:nvSpPr>
-          <p:cNvPr id="19" name="ingestion-5">
-            <a:extLst xmlns:a="http://schemas.openxmlformats.org/drawingml/2006/main">
-              <a:ext uri="{FF2B5EF4-FFF2-40B4-BE49-F238E27FC236}">
-                <a16:creationId xmlns:a16="http://schemas.microsoft.com/office/drawing/2014/main" id="{43F7E1B1-E237-4A79-B0C4-38965CF32D74}"/>
-              </a:ext>
-            </a:extLst>
-          </p:cNvPr>
-          <p:cNvSpPr>
-            <a:spLocks xmlns:a="http://schemas.openxmlformats.org/drawingml/2006/main" noGrp="1"/>
-          </p:cNvSpPr>
-          <p:nvPr/>
-        </p:nvSpPr>
-        <p:spPr>
-          <a:xfrm xmlns:a="http://schemas.openxmlformats.org/drawingml/2006/main">
-            <a:off x="12268200" y="3086100"/>
-            <a:ext cx="2247900" cy="2266950"/>
-          </a:xfrm>
-          <a:prstGeom xmlns:a="http://schemas.openxmlformats.org/drawingml/2006/main" prst="roundRect">
-            <a:avLst>
-              <a:gd name="adj" fmla="val 5085"/>
-            </a:avLst>
-          </a:prstGeom>
-          <a:solidFill xmlns:a="http://schemas.openxmlformats.org/drawingml/2006/main">
-            <a:srgbClr val="FFFFFF"/>
-          </a:solidFill>
-          <a:ln xmlns:a="http://schemas.openxmlformats.org/drawingml/2006/main" w="19050">
-            <a:solidFill>
-              <a:srgbClr val="F07D00"/>
-            </a:solidFill>
-            <a:prstDash val="solid"/>
-          </a:ln>
-        </p:spPr>
-      </p:sp>
-      <p:sp>
-        <p:nvSpPr>
-          <p:cNvPr id="20" name="">
-            <a:extLst xmlns:a="http://schemas.openxmlformats.org/drawingml/2006/main">
-              <a:ext uri="{FF2B5EF4-FFF2-40B4-BE49-F238E27FC236}">
-                <a16:creationId xmlns:a16="http://schemas.microsoft.com/office/drawing/2014/main" id="{51764D39-05B0-4F08-BC2B-2221BE2F38D6}"/>
-              </a:ext>
-            </a:extLst>
-          </p:cNvPr>
-          <p:cNvSpPr>
-            <a:spLocks xmlns:a="http://schemas.openxmlformats.org/drawingml/2006/main" noGrp="1"/>
-          </p:cNvSpPr>
-          <p:nvPr/>
-        </p:nvSpPr>
-        <p:spPr>
-          <a:xfrm xmlns:a="http://schemas.openxmlformats.org/drawingml/2006/main">
-            <a:off x="12458700" y="3295650"/>
-            <a:ext cx="514350" cy="285750"/>
-          </a:xfrm>
-          <a:prstGeom xmlns:a="http://schemas.openxmlformats.org/drawingml/2006/main" prst="rect">
-            <a:avLst/>
-          </a:prstGeom>
-          <a:noFill xmlns:a="http://schemas.openxmlformats.org/drawingml/2006/main"/>
-          <a:ln xmlns:a="http://schemas.openxmlformats.org/drawingml/2006/main" w="0">
-            <a:noFill/>
-            <a:prstDash val="solid"/>
-          </a:ln>
-        </p:spPr>
-        <p:txBody>
-          <a:bodyPr xmlns:a="http://schemas.openxmlformats.org/drawingml/2006/main" wrap="square" lIns="0" tIns="0" rIns="0" bIns="0" anchor="ctr">
-            <a:noAutofit/>
-          </a:bodyPr>
-          <a:lstStyle xmlns:a="http://schemas.openxmlformats.org/drawingml/2006/main"/>
-          <a:p xmlns:a="http://schemas.openxmlformats.org/drawingml/2006/main">
-            <a:pPr algn="l">
-              <a:lnSpc>
-                <a:spcPct val="100000"/>
-              </a:lnSpc>
-              <a:buNone/>
-              <a:defRPr sz="1350" b="1">
-                <a:solidFill>
-                  <a:srgbClr val="00A2EB"/>
-                </a:solidFill>
-                <a:latin typeface="Calibri"/>
-                <a:ea typeface="Calibri"/>
-                <a:cs typeface="Calibri"/>
-              </a:defRPr>
-            </a:pPr>
-            <a:r>
-              <a:rPr sz="1800" b="1">
-                <a:solidFill>
-                  <a:srgbClr val="00A2EB"/>
-                </a:solidFill>
-                <a:latin typeface="Calibri"/>
-                <a:ea typeface="Calibri"/>
-                <a:cs typeface="Calibri"/>
-              </a:rPr>
-              <a:t>05</a:t>
-            </a:r>
-          </a:p>
-        </p:txBody>
-      </p:sp>
-      <p:sp>
-        <p:nvSpPr>
-          <p:cNvPr id="21" name="">
-            <a:extLst xmlns:a="http://schemas.openxmlformats.org/drawingml/2006/main">
-              <a:ext uri="{FF2B5EF4-FFF2-40B4-BE49-F238E27FC236}">
-                <a16:creationId xmlns:a16="http://schemas.microsoft.com/office/drawing/2014/main" id="{C0F4CBB5-9FF7-4C7B-8D8C-5AA3541DD5E4}"/>
-              </a:ext>
-            </a:extLst>
-          </p:cNvPr>
-          <p:cNvSpPr>
-            <a:spLocks xmlns:a="http://schemas.openxmlformats.org/drawingml/2006/main" noGrp="1"/>
-          </p:cNvSpPr>
-          <p:nvPr/>
-        </p:nvSpPr>
-        <p:spPr>
-          <a:xfrm xmlns:a="http://schemas.openxmlformats.org/drawingml/2006/main">
-            <a:off x="12382500" y="3752850"/>
-            <a:ext cx="2019300" cy="685800"/>
-          </a:xfrm>
-          <a:prstGeom xmlns:a="http://schemas.openxmlformats.org/drawingml/2006/main" prst="rect">
-            <a:avLst/>
-          </a:prstGeom>
-          <a:noFill xmlns:a="http://schemas.openxmlformats.org/drawingml/2006/main"/>
-          <a:ln xmlns:a="http://schemas.openxmlformats.org/drawingml/2006/main" w="0">
-            <a:noFill/>
-            <a:prstDash val="solid"/>
-          </a:ln>
-        </p:spPr>
-        <p:txBody>
-          <a:bodyPr xmlns:a="http://schemas.openxmlformats.org/drawingml/2006/main" wrap="square" lIns="0" tIns="0" rIns="0" bIns="0" anchor="ctr">
-            <a:normAutofit fontScale="100000"/>
-          </a:bodyPr>
-          <a:lstStyle xmlns:a="http://schemas.openxmlformats.org/drawingml/2006/main"/>
-          <a:p xmlns:a="http://schemas.openxmlformats.org/drawingml/2006/main">
-            <a:pPr algn="l">
-              <a:lnSpc>
-                <a:spcPct val="100000"/>
-              </a:lnSpc>
-              <a:buNone/>
-              <a:defRPr sz="1950" b="1">
-                <a:solidFill>
-                  <a:srgbClr val="051C2A"/>
-                </a:solidFill>
-                <a:latin typeface="Calibri"/>
-                <a:ea typeface="Calibri"/>
-                <a:cs typeface="Calibri"/>
-              </a:defRPr>
-            </a:pPr>
-            <a:r>
-              <a:rPr sz="1950" b="1">
-                <a:solidFill>
-                  <a:srgbClr val="051C2A"/>
-                </a:solidFill>
-                <a:latin typeface="Calibri"/>
-                <a:ea typeface="Calibri"/>
-                <a:cs typeface="Calibri"/>
-              </a:rPr>
-              <a:t>STATE</a:t>
-            </a:r>
-          </a:p>
-        </p:txBody>
-      </p:sp>
-      <p:sp>
-        <p:nvSpPr>
-          <p:cNvPr id="22" name="">
-            <a:extLst xmlns:a="http://schemas.openxmlformats.org/drawingml/2006/main">
-              <a:ext uri="{FF2B5EF4-FFF2-40B4-BE49-F238E27FC236}">
-                <a16:creationId xmlns:a16="http://schemas.microsoft.com/office/drawing/2014/main" id="{8856B515-B8BF-4B9C-8D6B-EC909D2B3B4E}"/>
-              </a:ext>
-            </a:extLst>
-          </p:cNvPr>
-          <p:cNvSpPr>
-            <a:spLocks xmlns:a="http://schemas.openxmlformats.org/drawingml/2006/main" noGrp="1"/>
-          </p:cNvSpPr>
-          <p:nvPr/>
-        </p:nvSpPr>
-        <p:spPr>
-          <a:xfrm xmlns:a="http://schemas.openxmlformats.org/drawingml/2006/main">
-            <a:off x="12458700" y="4610100"/>
-            <a:ext cx="1866900" cy="514350"/>
-          </a:xfrm>
-          <a:prstGeom xmlns:a="http://schemas.openxmlformats.org/drawingml/2006/main" prst="rect">
-            <a:avLst/>
-          </a:prstGeom>
-          <a:noFill xmlns:a="http://schemas.openxmlformats.org/drawingml/2006/main"/>
-          <a:ln xmlns:a="http://schemas.openxmlformats.org/drawingml/2006/main" w="0">
-            <a:noFill/>
-            <a:prstDash val="solid"/>
-          </a:ln>
-        </p:spPr>
-        <p:txBody>
-          <a:bodyPr xmlns:a="http://schemas.openxmlformats.org/drawingml/2006/main" wrap="square" lIns="0" tIns="0" rIns="0" bIns="0" anchor="ctr">
-            <a:normAutofit fontScale="100000"/>
-          </a:bodyPr>
-          <a:lstStyle xmlns:a="http://schemas.openxmlformats.org/drawingml/2006/main"/>
-          <a:p xmlns:a="http://schemas.openxmlformats.org/drawingml/2006/main">
-            <a:pPr algn="l">
-              <a:lnSpc>
-                <a:spcPct val="100000"/>
-              </a:lnSpc>
-              <a:buNone/>
-              <a:defRPr sz="1200" b="0">
-                <a:solidFill>
-                  <a:srgbClr val="1F40CB"/>
-                </a:solidFill>
-                <a:latin typeface="Calibri"/>
-                <a:ea typeface="Calibri"/>
-                <a:cs typeface="Calibri"/>
-              </a:defRPr>
-            </a:pPr>
-            <a:r>
-              <a:rPr sz="1200" b="0">
-                <a:solidFill>
-                  <a:srgbClr val="1F40CB"/>
-                </a:solidFill>
-                <a:latin typeface="Calibri"/>
-                <a:ea typeface="Calibri"/>
-                <a:cs typeface="Calibri"/>
-              </a:rPr>
-              <a:t>host owned</a:t>
-            </a:r>
-          </a:p>
-        </p:txBody>
-      </p:sp>
-      <p:cxnSp>
-        <p:nvCxnSpPr>
-          <p:cNvPr id="629" name=""/>
-          <p:cNvCxnSpPr>
-            <a:stCxn xmlns:a="http://schemas.openxmlformats.org/drawingml/2006/main" id="3" idx="3"/>
-            <a:endCxn xmlns:a="http://schemas.openxmlformats.org/drawingml/2006/main" id="7" idx="1"/>
-          </p:cNvCxnSpPr>
-          <p:nvPr/>
-        </p:nvCxnSpPr>
-        <p:spPr>
-          <a:xfrm xmlns:a="http://schemas.openxmlformats.org/drawingml/2006/main">
-            <a:off x="3238500" y="4219575"/>
-            <a:ext cx="571500" cy="0"/>
-          </a:xfrm>
-          <a:prstGeom xmlns:a="http://schemas.openxmlformats.org/drawingml/2006/main" prst="straightConnector1">
-            <a:avLst/>
-          </a:prstGeom>
-          <a:ln xmlns:a="http://schemas.openxmlformats.org/drawingml/2006/main" w="28575">
-            <a:solidFill>
-              <a:srgbClr val="9A9A9F"/>
-            </a:solidFill>
-            <a:prstDash val="solid"/>
-            <a:tailEnd type="triangle" w="med" len="med"/>
-          </a:ln>
-        </p:spPr>
-      </p:cxnSp>
-      <p:cxnSp>
-        <p:nvCxnSpPr>
-          <p:cNvPr id="630" name=""/>
-          <p:cNvCxnSpPr>
-            <a:stCxn xmlns:a="http://schemas.openxmlformats.org/drawingml/2006/main" id="7" idx="3"/>
-            <a:endCxn xmlns:a="http://schemas.openxmlformats.org/drawingml/2006/main" id="11" idx="1"/>
-          </p:cNvCxnSpPr>
-          <p:nvPr/>
-        </p:nvCxnSpPr>
-        <p:spPr>
-          <a:xfrm xmlns:a="http://schemas.openxmlformats.org/drawingml/2006/main">
-            <a:off x="6057900" y="4219575"/>
-            <a:ext cx="571500" cy="0"/>
-          </a:xfrm>
-          <a:prstGeom xmlns:a="http://schemas.openxmlformats.org/drawingml/2006/main" prst="straightConnector1">
-            <a:avLst/>
-          </a:prstGeom>
-          <a:ln xmlns:a="http://schemas.openxmlformats.org/drawingml/2006/main" w="28575">
-            <a:solidFill>
-              <a:srgbClr val="9A9A9F"/>
-            </a:solidFill>
-            <a:prstDash val="solid"/>
-            <a:tailEnd type="triangle" w="med" len="med"/>
-          </a:ln>
-        </p:spPr>
-      </p:cxnSp>
-      <p:cxnSp>
-        <p:nvCxnSpPr>
-          <p:cNvPr id="631" name=""/>
-          <p:cNvCxnSpPr>
-            <a:stCxn xmlns:a="http://schemas.openxmlformats.org/drawingml/2006/main" id="11" idx="3"/>
-            <a:endCxn xmlns:a="http://schemas.openxmlformats.org/drawingml/2006/main" id="15" idx="1"/>
-          </p:cNvCxnSpPr>
-          <p:nvPr/>
-        </p:nvCxnSpPr>
-        <p:spPr>
-          <a:xfrm xmlns:a="http://schemas.openxmlformats.org/drawingml/2006/main">
-            <a:off x="8877300" y="4219575"/>
-            <a:ext cx="571500" cy="0"/>
-          </a:xfrm>
-          <a:prstGeom xmlns:a="http://schemas.openxmlformats.org/drawingml/2006/main" prst="straightConnector1">
-            <a:avLst/>
-          </a:prstGeom>
-          <a:ln xmlns:a="http://schemas.openxmlformats.org/drawingml/2006/main" w="28575">
-            <a:solidFill>
-              <a:srgbClr val="9A9A9F"/>
-            </a:solidFill>
-            <a:prstDash val="solid"/>
-            <a:tailEnd type="triangle" w="med" len="med"/>
-          </a:ln>
-        </p:spPr>
-      </p:cxnSp>
-      <p:cxnSp>
-        <p:nvCxnSpPr>
-          <p:cNvPr id="632" name=""/>
-          <p:cNvCxnSpPr>
-            <a:stCxn xmlns:a="http://schemas.openxmlformats.org/drawingml/2006/main" id="15" idx="3"/>
-            <a:endCxn xmlns:a="http://schemas.openxmlformats.org/drawingml/2006/main" id="19" idx="1"/>
-          </p:cNvCxnSpPr>
-          <p:nvPr/>
-        </p:nvCxnSpPr>
-        <p:spPr>
-          <a:xfrm xmlns:a="http://schemas.openxmlformats.org/drawingml/2006/main">
-            <a:off x="11696700" y="4219575"/>
-            <a:ext cx="571500" cy="0"/>
-          </a:xfrm>
-          <a:prstGeom xmlns:a="http://schemas.openxmlformats.org/drawingml/2006/main" prst="straightConnector1">
-            <a:avLst/>
-          </a:prstGeom>
-          <a:ln xmlns:a="http://schemas.openxmlformats.org/drawingml/2006/main" w="28575">
-            <a:solidFill>
-              <a:srgbClr val="9A9A9F"/>
-            </a:solidFill>
-            <a:prstDash val="solid"/>
-            <a:tailEnd type="triangle" w="med" len="med"/>
-          </a:ln>
-        </p:spPr>
-      </p:cxnSp>
-      <p:sp>
-        <p:nvSpPr>
-          <p:cNvPr id="27" name="">
-            <a:extLst xmlns:a="http://schemas.openxmlformats.org/drawingml/2006/main">
-              <a:ext uri="{FF2B5EF4-FFF2-40B4-BE49-F238E27FC236}">
-                <a16:creationId xmlns:a16="http://schemas.microsoft.com/office/drawing/2014/main" id="{79128475-820B-447C-A724-7D8A31328FFE}"/>
-              </a:ext>
-            </a:extLst>
-          </p:cNvPr>
-          <p:cNvSpPr>
-            <a:spLocks xmlns:a="http://schemas.openxmlformats.org/drawingml/2006/main" noGrp="1"/>
-          </p:cNvSpPr>
-          <p:nvPr/>
-        </p:nvSpPr>
-        <p:spPr>
-          <a:xfrm xmlns:a="http://schemas.openxmlformats.org/drawingml/2006/main">
-            <a:off x="2381250" y="6210300"/>
-            <a:ext cx="10477500" cy="457200"/>
-          </a:xfrm>
-          <a:prstGeom xmlns:a="http://schemas.openxmlformats.org/drawingml/2006/main" prst="rect">
-            <a:avLst/>
-          </a:prstGeom>
-          <a:noFill xmlns:a="http://schemas.openxmlformats.org/drawingml/2006/main"/>
-          <a:ln xmlns:a="http://schemas.openxmlformats.org/drawingml/2006/main" w="0">
-            <a:noFill/>
-            <a:prstDash val="solid"/>
-          </a:ln>
-        </p:spPr>
-        <p:txBody>
-          <a:bodyPr xmlns:a="http://schemas.openxmlformats.org/drawingml/2006/main" wrap="square" lIns="0" tIns="0" rIns="0" bIns="0" anchor="ctr">
-            <a:normAutofit fontScale="100000"/>
-          </a:bodyPr>
-          <a:lstStyle xmlns:a="http://schemas.openxmlformats.org/drawingml/2006/main"/>
-          <a:p xmlns:a="http://schemas.openxmlformats.org/drawingml/2006/main">
-            <a:pPr algn="ctr">
-              <a:lnSpc>
-                <a:spcPct val="100000"/>
-              </a:lnSpc>
-              <a:buNone/>
-              <a:defRPr sz="2100" b="1">
-                <a:solidFill>
-                  <a:srgbClr val="051C2A"/>
-                </a:solidFill>
-                <a:latin typeface="Calibri"/>
-                <a:ea typeface="Calibri"/>
-                <a:cs typeface="Calibri"/>
-              </a:defRPr>
-            </a:pPr>
-            <a:r>
-              <a:rPr sz="2100" b="1">
-                <a:solidFill>
-                  <a:srgbClr val="051C2A"/>
-                </a:solidFill>
-                <a:latin typeface="Calibri"/>
-                <a:ea typeface="Calibri"/>
-                <a:cs typeface="Calibri"/>
-              </a:rPr>
-              <a:t>Four roles work through one host-owned state.</a:t>
-            </a:r>
-          </a:p>
-        </p:txBody>
-      </p:sp>
-      <p:sp>
-        <p:nvSpPr>
-          <p:cNvPr id="28" name="">
-            <a:extLst xmlns:a="http://schemas.openxmlformats.org/drawingml/2006/main">
-              <a:ext uri="{FF2B5EF4-FFF2-40B4-BE49-F238E27FC236}">
-                <a16:creationId xmlns:a16="http://schemas.microsoft.com/office/drawing/2014/main" id="{685F2AAD-81FC-436A-88F7-89F49C9F1671}"/>
-              </a:ext>
-            </a:extLst>
-          </p:cNvPr>
-          <p:cNvSpPr>
-            <a:spLocks xmlns:a="http://schemas.openxmlformats.org/drawingml/2006/main" noGrp="1"/>
-          </p:cNvSpPr>
-          <p:nvPr/>
-        </p:nvSpPr>
-        <p:spPr>
-          <a:xfrm xmlns:a="http://schemas.openxmlformats.org/drawingml/2006/main">
-            <a:off x="1885950" y="6838950"/>
-            <a:ext cx="4476750" cy="323850"/>
-          </a:xfrm>
-          <a:prstGeom xmlns:a="http://schemas.openxmlformats.org/drawingml/2006/main" prst="rect">
-            <a:avLst/>
-          </a:prstGeom>
-          <a:noFill xmlns:a="http://schemas.openxmlformats.org/drawingml/2006/main"/>
-          <a:ln xmlns:a="http://schemas.openxmlformats.org/drawingml/2006/main" w="0">
-            <a:noFill/>
-            <a:prstDash val="solid"/>
-          </a:ln>
-        </p:spPr>
-        <p:txBody>
-          <a:bodyPr xmlns:a="http://schemas.openxmlformats.org/drawingml/2006/main" wrap="square" lIns="0" tIns="0" rIns="0" bIns="0" anchor="ctr">
-            <a:normAutofit fontScale="100000"/>
-          </a:bodyPr>
-          <a:lstStyle xmlns:a="http://schemas.openxmlformats.org/drawingml/2006/main"/>
-          <a:p xmlns:a="http://schemas.openxmlformats.org/drawingml/2006/main">
-            <a:pPr algn="ctr">
-              <a:lnSpc>
-                <a:spcPct val="100000"/>
-              </a:lnSpc>
-              <a:buNone/>
-              <a:defRPr sz="1500" b="0">
-                <a:solidFill>
-                  <a:srgbClr val="64748B"/>
-                </a:solidFill>
-                <a:latin typeface="Calibri"/>
-                <a:ea typeface="Calibri"/>
-                <a:cs typeface="Calibri"/>
-              </a:defRPr>
-            </a:pPr>
-            <a:r>
-              <a:rPr sz="1500" b="0">
-                <a:solidFill>
-                  <a:srgbClr val="64748B"/>
-                </a:solidFill>
-                <a:latin typeface="Calibri"/>
-                <a:ea typeface="Calibri"/>
-                <a:cs typeface="Calibri"/>
-              </a:rPr>
-              <a:t>append-only observations</a:t>
-            </a:r>
-          </a:p>
-        </p:txBody>
-      </p:sp>
-      <p:sp>
-        <p:nvSpPr>
-          <p:cNvPr id="29" name="">
-            <a:extLst xmlns:a="http://schemas.openxmlformats.org/drawingml/2006/main">
-              <a:ext uri="{FF2B5EF4-FFF2-40B4-BE49-F238E27FC236}">
-                <a16:creationId xmlns:a16="http://schemas.microsoft.com/office/drawing/2014/main" id="{CDE04AD7-6CBE-4792-B549-765578FB3E1E}"/>
-              </a:ext>
-            </a:extLst>
-          </p:cNvPr>
-          <p:cNvSpPr>
-            <a:spLocks xmlns:a="http://schemas.openxmlformats.org/drawingml/2006/main" noGrp="1"/>
-          </p:cNvSpPr>
-          <p:nvPr/>
-        </p:nvSpPr>
-        <p:spPr>
-          <a:xfrm xmlns:a="http://schemas.openxmlformats.org/drawingml/2006/main">
-            <a:off x="8801100" y="6838950"/>
-            <a:ext cx="4762500" cy="323850"/>
-          </a:xfrm>
-          <a:prstGeom xmlns:a="http://schemas.openxmlformats.org/drawingml/2006/main" prst="rect">
-            <a:avLst/>
-          </a:prstGeom>
-          <a:noFill xmlns:a="http://schemas.openxmlformats.org/drawingml/2006/main"/>
-          <a:ln xmlns:a="http://schemas.openxmlformats.org/drawingml/2006/main" w="0">
-            <a:noFill/>
-            <a:prstDash val="solid"/>
-          </a:ln>
-        </p:spPr>
-        <p:txBody>
-          <a:bodyPr xmlns:a="http://schemas.openxmlformats.org/drawingml/2006/main" wrap="square" lIns="0" tIns="0" rIns="0" bIns="0" anchor="ctr">
-            <a:normAutofit fontScale="100000"/>
-          </a:bodyPr>
-          <a:lstStyle xmlns:a="http://schemas.openxmlformats.org/drawingml/2006/main"/>
-          <a:p xmlns:a="http://schemas.openxmlformats.org/drawingml/2006/main">
-            <a:pPr algn="ctr">
-              <a:lnSpc>
-                <a:spcPct val="100000"/>
-              </a:lnSpc>
-              <a:buNone/>
-              <a:defRPr sz="1500" b="0">
-                <a:solidFill>
-                  <a:srgbClr val="64748B"/>
-                </a:solidFill>
-                <a:latin typeface="Calibri"/>
-                <a:ea typeface="Calibri"/>
-                <a:cs typeface="Calibri"/>
-              </a:defRPr>
-            </a:pPr>
-            <a:r>
-              <a:rPr sz="1500" b="0">
-                <a:solidFill>
-                  <a:srgbClr val="64748B"/>
-                </a:solidFill>
-                <a:latin typeface="Calibri"/>
-                <a:ea typeface="Calibri"/>
-                <a:cs typeface="Calibri"/>
-              </a:rPr>
-              <a:t>one replan maximum</a:t>
-            </a:r>
-          </a:p>
-        </p:txBody>
-      </p:sp>
-      <p:sp>
-        <p:nvSpPr>
-          <p:cNvPr id="30" name="">
-            <a:extLst xmlns:a="http://schemas.openxmlformats.org/drawingml/2006/main">
-              <a:ext uri="{FF2B5EF4-FFF2-40B4-BE49-F238E27FC236}">
-                <a16:creationId xmlns:a16="http://schemas.microsoft.com/office/drawing/2014/main" id="{28CBA7AE-993C-4F84-A696-8D1323AC4E80}"/>
+              <a:t>Every node reads or updates the same bounded state.</a:t>
+            </a:r>
+          </a:p>
+        </p:txBody>
+      </p:sp>
+      <p:sp>
+        <p:nvSpPr>
+          <p:cNvPr id="23" name="">
+            <a:extLst xmlns:a="http://schemas.openxmlformats.org/drawingml/2006/main">
+              <a:ext uri="{FF2B5EF4-FFF2-40B4-BE49-F238E27FC236}">
+                <a16:creationId xmlns:a16="http://schemas.microsoft.com/office/drawing/2014/main" id="{3CA8D079-E333-430B-9198-F3840FF42229}"/>
               </a:ext>
             </a:extLst>
           </p:cNvPr>
@@ -8816,10 +8614,10 @@
       </p:sp>
       <p:sp>
         <p:nvSpPr>
-          <p:cNvPr id="31" name="">
-            <a:extLst xmlns:a="http://schemas.openxmlformats.org/drawingml/2006/main">
-              <a:ext uri="{FF2B5EF4-FFF2-40B4-BE49-F238E27FC236}">
-                <a16:creationId xmlns:a16="http://schemas.microsoft.com/office/drawing/2014/main" id="{DE97BF4D-EDBC-4480-A82B-512A72221950}"/>
+          <p:cNvPr id="24" name="">
+            <a:extLst xmlns:a="http://schemas.openxmlformats.org/drawingml/2006/main">
+              <a:ext uri="{FF2B5EF4-FFF2-40B4-BE49-F238E27FC236}">
+                <a16:creationId xmlns:a16="http://schemas.microsoft.com/office/drawing/2014/main" id="{56B1FA6E-7D19-4BD4-95AB-A7A96F2D9D4D}"/>
               </a:ext>
             </a:extLst>
           </p:cNvPr>
@@ -8849,10 +8647,10 @@
       </p:sp>
       <p:sp>
         <p:nvSpPr>
-          <p:cNvPr id="32" name="">
-            <a:extLst xmlns:a="http://schemas.openxmlformats.org/drawingml/2006/main">
-              <a:ext uri="{FF2B5EF4-FFF2-40B4-BE49-F238E27FC236}">
-                <a16:creationId xmlns:a16="http://schemas.microsoft.com/office/drawing/2014/main" id="{49281B64-2F0F-4357-A085-C65451F28236}"/>
+          <p:cNvPr id="25" name="">
+            <a:extLst xmlns:a="http://schemas.openxmlformats.org/drawingml/2006/main">
+              <a:ext uri="{FF2B5EF4-FFF2-40B4-BE49-F238E27FC236}">
+                <a16:creationId xmlns:a16="http://schemas.microsoft.com/office/drawing/2014/main" id="{C621D69C-B05C-4F0B-A6BD-0B4E43C7FA72}"/>
               </a:ext>
             </a:extLst>
           </p:cNvPr>
@@ -8911,10 +8709,10 @@
       </p:sp>
       <p:sp>
         <p:nvSpPr>
-          <p:cNvPr id="33" name="">
-            <a:extLst xmlns:a="http://schemas.openxmlformats.org/drawingml/2006/main">
-              <a:ext uri="{FF2B5EF4-FFF2-40B4-BE49-F238E27FC236}">
-                <a16:creationId xmlns:a16="http://schemas.microsoft.com/office/drawing/2014/main" id="{EAA325A4-7EC6-42CE-A13A-4B38A32DE7F2}"/>
+          <p:cNvPr id="26" name="">
+            <a:extLst xmlns:a="http://schemas.openxmlformats.org/drawingml/2006/main">
+              <a:ext uri="{FF2B5EF4-FFF2-40B4-BE49-F238E27FC236}">
+                <a16:creationId xmlns:a16="http://schemas.microsoft.com/office/drawing/2014/main" id="{84A9C6EC-5AC1-4AD4-9D79-D0462CD01225}"/>
               </a:ext>
             </a:extLst>
           </p:cNvPr>
@@ -8973,10 +8771,10 @@
       </p:sp>
       <p:sp>
         <p:nvSpPr>
-          <p:cNvPr id="34" name="">
-            <a:extLst xmlns:a="http://schemas.openxmlformats.org/drawingml/2006/main">
-              <a:ext uri="{FF2B5EF4-FFF2-40B4-BE49-F238E27FC236}">
-                <a16:creationId xmlns:a16="http://schemas.microsoft.com/office/drawing/2014/main" id="{5F7FB65A-4A0D-4595-92F4-FD9B71638842}"/>
+          <p:cNvPr id="27" name="">
+            <a:extLst xmlns:a="http://schemas.openxmlformats.org/drawingml/2006/main">
+              <a:ext uri="{FF2B5EF4-FFF2-40B4-BE49-F238E27FC236}">
+                <a16:creationId xmlns:a16="http://schemas.microsoft.com/office/drawing/2014/main" id="{E30F561A-2997-41E1-8361-56739584F871}"/>
               </a:ext>
             </a:extLst>
           </p:cNvPr>
@@ -9036,7 +8834,7 @@
     </p:spTree>
     <p:extLst>
       <p:ext uri="{BB962C8B-B14F-4D97-AF65-F5344CB8AC3E}">
-        <p14:creationId xmlns:p14="http://schemas.microsoft.com/office/powerpoint/2010/main" val="1169510731"/>
+        <p14:creationId xmlns:p14="http://schemas.microsoft.com/office/powerpoint/2010/main" val="1663571577"/>
       </p:ext>
     </p:extLst>
   </p:cSld>

</xml_diff>